<commit_message>
deck slide 6: 3-column roadmap (Before / During / After) + status badges
Replaces the 2-column forward-looking layout with the user-specified
3-column structure. Each phase has its own accent + status badge under
the bilingual header so the state reads at a glance:

  Before  (rightmost, green RESOLVER)  ✅ مكتمل
  During  (middle,    blue  MEMORY)    ⏳ قيد التنفيذ
  After   (leftmost,  gray  SECONDARY) 🚀 مخطط

Items rewritten per user spec — concise Arabic with English technical
terms preserved (PRD, Agent Specs, Fork, Claude API, RAG, NCA
compliance, SaaS, Slack, Teams).
</commit_message>
<xml_diff>
--- a/docs/pitch-deck.pptx
+++ b/docs/pitch-deck.pptx
@@ -7322,8 +7322,8 @@
         </p:nvSpPr>
         <p:spPr>
           <a:xfrm>
-            <a:off x="6277356" y="1783080"/>
-            <a:ext cx="4539996" cy="4663440"/>
+            <a:off x="8095488" y="1691640"/>
+            <a:ext cx="3544824" cy="4754880"/>
           </a:xfrm>
           <a:prstGeom prst="roundRect">
             <a:avLst>
@@ -7369,14 +7369,14 @@
         </p:nvSpPr>
         <p:spPr>
           <a:xfrm>
-            <a:off x="6277356" y="1783080"/>
-            <a:ext cx="4539996" cy="54864"/>
+            <a:off x="8095488" y="1691640"/>
+            <a:ext cx="3544824" cy="54864"/>
           </a:xfrm>
           <a:prstGeom prst="rect">
             <a:avLst/>
           </a:prstGeom>
           <a:solidFill>
-            <a:srgbClr val="FBBF24"/>
+            <a:srgbClr val="4ADE80"/>
           </a:solidFill>
           <a:ln>
             <a:noFill/>
@@ -7412,8 +7412,8 @@
         </p:nvSpPr>
         <p:spPr>
           <a:xfrm>
-            <a:off x="6505956" y="2029968"/>
-            <a:ext cx="4082796" cy="457200"/>
+            <a:off x="8296656" y="1892808"/>
+            <a:ext cx="3142488" cy="411480"/>
           </a:xfrm>
           <a:prstGeom prst="rect">
             <a:avLst/>
@@ -7428,13 +7428,13 @@
           <a:p>
             <a:pPr algn="r" rtl="1"/>
             <a:r>
-              <a:rPr sz="1500" b="1" i="0">
-                <a:solidFill>
-                  <a:srgbClr val="FBBF24"/>
-                </a:solidFill>
-                <a:latin typeface="IBM Plex Sans Arabic"/>
-              </a:rPr>
-              <a:t>الهاكاثون — ٣ أيام</a:t>
+              <a:rPr sz="1700" b="1" i="0">
+                <a:solidFill>
+                  <a:srgbClr val="4ADE80"/>
+                </a:solidFill>
+                <a:latin typeface="IBM Plex Sans Arabic"/>
+              </a:rPr>
+              <a:t>قبل الهاكاثون</a:t>
             </a:r>
           </a:p>
         </p:txBody>
@@ -7447,8 +7447,8 @@
         </p:nvSpPr>
         <p:spPr>
           <a:xfrm>
-            <a:off x="6505956" y="2496312"/>
-            <a:ext cx="4082796" cy="292608"/>
+            <a:off x="8296656" y="2331720"/>
+            <a:ext cx="3142488" cy="274320"/>
           </a:xfrm>
           <a:prstGeom prst="rect">
             <a:avLst/>
@@ -7469,7 +7469,7 @@
                 </a:solidFill>
                 <a:latin typeface="IBM Plex Sans Arabic"/>
               </a:rPr>
-              <a:t>Hackathon — 3 Days</a:t>
+              <a:t>Before</a:t>
             </a:r>
           </a:p>
         </p:txBody>
@@ -7482,8 +7482,8 @@
         </p:nvSpPr>
         <p:spPr>
           <a:xfrm>
-            <a:off x="6505956" y="3063240"/>
-            <a:ext cx="4082796" cy="548640"/>
+            <a:off x="8296656" y="2651760"/>
+            <a:ext cx="3142488" cy="320040"/>
           </a:xfrm>
           <a:prstGeom prst="rect">
             <a:avLst/>
@@ -7498,36 +7498,115 @@
           <a:p>
             <a:pPr algn="r" rtl="1"/>
             <a:r>
+              <a:rPr sz="1200" b="1" i="0">
+                <a:solidFill>
+                  <a:srgbClr val="4ADE80"/>
+                </a:solidFill>
+                <a:latin typeface="IBM Plex Sans Arabic"/>
+              </a:rPr>
+              <a:t>✅  مكتمل</a:t>
+            </a:r>
+          </a:p>
+        </p:txBody>
+      </p:sp>
+      <p:sp>
+        <p:nvSpPr>
+          <p:cNvPr id="10" name="TextBox 9"/>
+          <p:cNvSpPr txBox="1"/>
+          <p:nvPr/>
+        </p:nvSpPr>
+        <p:spPr>
+          <a:xfrm>
+            <a:off x="8296656" y="3154680"/>
+            <a:ext cx="3142488" cy="548640"/>
+          </a:xfrm>
+          <a:prstGeom prst="rect">
+            <a:avLst/>
+          </a:prstGeom>
+          <a:noFill/>
+        </p:spPr>
+        <p:txBody>
+          <a:bodyPr wrap="square" lIns="0" rIns="0" tIns="0" bIns="0" anchor="t">
+            <a:spAutoFit/>
+          </a:bodyPr>
+          <a:lstStyle/>
+          <a:p>
+            <a:pPr algn="r" rtl="1"/>
+            <a:r>
+              <a:rPr sz="1100" b="0" i="0">
+                <a:solidFill>
+                  <a:srgbClr val="4ADE80"/>
+                </a:solidFill>
+                <a:latin typeface="IBM Plex Sans Arabic"/>
+              </a:rPr>
+              <a:t>●  </a:t>
+            </a:r>
+            <a:r>
               <a:rPr sz="1200" b="0" i="0">
                 <a:solidFill>
-                  <a:srgbClr val="FBBF24"/>
+                  <a:srgbClr val="F5F5F5"/>
+                </a:solidFill>
+                <a:latin typeface="IBM Plex Sans Arabic"/>
+              </a:rPr>
+              <a:t>تحليل السوق وتصميم البنية متعددة الوكلاء</a:t>
+            </a:r>
+          </a:p>
+        </p:txBody>
+      </p:sp>
+      <p:sp>
+        <p:nvSpPr>
+          <p:cNvPr id="11" name="TextBox 10"/>
+          <p:cNvSpPr txBox="1"/>
+          <p:nvPr/>
+        </p:nvSpPr>
+        <p:spPr>
+          <a:xfrm>
+            <a:off x="8296656" y="3703320"/>
+            <a:ext cx="3142488" cy="548640"/>
+          </a:xfrm>
+          <a:prstGeom prst="rect">
+            <a:avLst/>
+          </a:prstGeom>
+          <a:noFill/>
+        </p:spPr>
+        <p:txBody>
+          <a:bodyPr wrap="square" lIns="0" rIns="0" tIns="0" bIns="0" anchor="t">
+            <a:spAutoFit/>
+          </a:bodyPr>
+          <a:lstStyle/>
+          <a:p>
+            <a:pPr algn="r" rtl="1"/>
+            <a:r>
+              <a:rPr sz="1100" b="0" i="0">
+                <a:solidFill>
+                  <a:srgbClr val="4ADE80"/>
                 </a:solidFill>
                 <a:latin typeface="IBM Plex Sans Arabic"/>
               </a:rPr>
               <a:t>●  </a:t>
             </a:r>
             <a:r>
-              <a:rPr sz="1300" b="0" i="0">
+              <a:rPr sz="1200" b="0" i="0">
                 <a:solidFill>
                   <a:srgbClr val="F5F5F5"/>
                 </a:solidFill>
                 <a:latin typeface="IBM Plex Sans Arabic"/>
               </a:rPr>
-              <a:t>تشغيل الوكلاء الأربعة على Claude Sonnet</a:t>
-            </a:r>
-          </a:p>
-        </p:txBody>
-      </p:sp>
-      <p:sp>
-        <p:nvSpPr>
-          <p:cNvPr id="10" name="TextBox 9"/>
-          <p:cNvSpPr txBox="1"/>
-          <p:nvPr/>
-        </p:nvSpPr>
-        <p:spPr>
-          <a:xfrm>
-            <a:off x="6505956" y="3611880"/>
-            <a:ext cx="4082796" cy="548640"/>
+              <a:t>توثيق تقني كامل (PRD + Agent Specs)</a:t>
+            </a:r>
+          </a:p>
+        </p:txBody>
+      </p:sp>
+      <p:sp>
+        <p:nvSpPr>
+          <p:cNvPr id="12" name="TextBox 11"/>
+          <p:cNvSpPr txBox="1"/>
+          <p:nvPr/>
+        </p:nvSpPr>
+        <p:spPr>
+          <a:xfrm>
+            <a:off x="8296656" y="4251960"/>
+            <a:ext cx="3142488" cy="548640"/>
           </a:xfrm>
           <a:prstGeom prst="rect">
             <a:avLst/>
@@ -7542,154 +7621,66 @@
           <a:p>
             <a:pPr algn="r" rtl="1"/>
             <a:r>
+              <a:rPr sz="1100" b="0" i="0">
+                <a:solidFill>
+                  <a:srgbClr val="4ADE80"/>
+                </a:solidFill>
+                <a:latin typeface="IBM Plex Sans Arabic"/>
+              </a:rPr>
+              <a:t>●  </a:t>
+            </a:r>
+            <a:r>
               <a:rPr sz="1200" b="0" i="0">
                 <a:solidFill>
-                  <a:srgbClr val="FBBF24"/>
+                  <a:srgbClr val="F5F5F5"/>
+                </a:solidFill>
+                <a:latin typeface="IBM Plex Sans Arabic"/>
+              </a:rPr>
+              <a:t>Fork لـ Flicky وتعريب الواجهة</a:t>
+            </a:r>
+          </a:p>
+        </p:txBody>
+      </p:sp>
+      <p:sp>
+        <p:nvSpPr>
+          <p:cNvPr id="13" name="TextBox 12"/>
+          <p:cNvSpPr txBox="1"/>
+          <p:nvPr/>
+        </p:nvSpPr>
+        <p:spPr>
+          <a:xfrm>
+            <a:off x="8296656" y="4800600"/>
+            <a:ext cx="3142488" cy="548640"/>
+          </a:xfrm>
+          <a:prstGeom prst="rect">
+            <a:avLst/>
+          </a:prstGeom>
+          <a:noFill/>
+        </p:spPr>
+        <p:txBody>
+          <a:bodyPr wrap="square" lIns="0" rIns="0" tIns="0" bIns="0" anchor="t">
+            <a:spAutoFit/>
+          </a:bodyPr>
+          <a:lstStyle/>
+          <a:p>
+            <a:pPr algn="r" rtl="1"/>
+            <a:r>
+              <a:rPr sz="1100" b="0" i="0">
+                <a:solidFill>
+                  <a:srgbClr val="4ADE80"/>
                 </a:solidFill>
                 <a:latin typeface="IBM Plex Sans Arabic"/>
               </a:rPr>
               <a:t>●  </a:t>
             </a:r>
             <a:r>
-              <a:rPr sz="1300" b="0" i="0">
+              <a:rPr sz="1200" b="0" i="0">
                 <a:solidFill>
                   <a:srgbClr val="F5F5F5"/>
                 </a:solidFill>
                 <a:latin typeface="IBM Plex Sans Arabic"/>
               </a:rPr>
-              <a:t>بناء طبقة الاسترجاع (RAG) للسياسات وسجل البلاغات</a:t>
-            </a:r>
-          </a:p>
-        </p:txBody>
-      </p:sp>
-      <p:sp>
-        <p:nvSpPr>
-          <p:cNvPr id="11" name="TextBox 10"/>
-          <p:cNvSpPr txBox="1"/>
-          <p:nvPr/>
-        </p:nvSpPr>
-        <p:spPr>
-          <a:xfrm>
-            <a:off x="6505956" y="4160520"/>
-            <a:ext cx="4082796" cy="548640"/>
-          </a:xfrm>
-          <a:prstGeom prst="rect">
-            <a:avLst/>
-          </a:prstGeom>
-          <a:noFill/>
-        </p:spPr>
-        <p:txBody>
-          <a:bodyPr wrap="square" lIns="0" rIns="0" tIns="0" bIns="0" anchor="t">
-            <a:spAutoFit/>
-          </a:bodyPr>
-          <a:lstStyle/>
-          <a:p>
-            <a:pPr algn="r" rtl="1"/>
-            <a:r>
-              <a:rPr sz="1200" b="0" i="0">
-                <a:solidFill>
-                  <a:srgbClr val="FBBF24"/>
-                </a:solidFill>
-                <a:latin typeface="IBM Plex Sans Arabic"/>
-              </a:rPr>
-              <a:t>●  </a:t>
-            </a:r>
-            <a:r>
-              <a:rPr sz="1300" b="0" i="0">
-                <a:solidFill>
-                  <a:srgbClr val="F5F5F5"/>
-                </a:solidFill>
-                <a:latin typeface="IBM Plex Sans Arabic"/>
-              </a:rPr>
-              <a:t>سيناريو VPN متعدد المستخدمين كاملاً</a:t>
-            </a:r>
-          </a:p>
-        </p:txBody>
-      </p:sp>
-      <p:sp>
-        <p:nvSpPr>
-          <p:cNvPr id="12" name="TextBox 11"/>
-          <p:cNvSpPr txBox="1"/>
-          <p:nvPr/>
-        </p:nvSpPr>
-        <p:spPr>
-          <a:xfrm>
-            <a:off x="6505956" y="4709160"/>
-            <a:ext cx="4082796" cy="548640"/>
-          </a:xfrm>
-          <a:prstGeom prst="rect">
-            <a:avLst/>
-          </a:prstGeom>
-          <a:noFill/>
-        </p:spPr>
-        <p:txBody>
-          <a:bodyPr wrap="square" lIns="0" rIns="0" tIns="0" bIns="0" anchor="t">
-            <a:spAutoFit/>
-          </a:bodyPr>
-          <a:lstStyle/>
-          <a:p>
-            <a:pPr algn="r" rtl="1"/>
-            <a:r>
-              <a:rPr sz="1200" b="0" i="0">
-                <a:solidFill>
-                  <a:srgbClr val="FBBF24"/>
-                </a:solidFill>
-                <a:latin typeface="IBM Plex Sans Arabic"/>
-              </a:rPr>
-              <a:t>●  </a:t>
-            </a:r>
-            <a:r>
-              <a:rPr sz="1300" b="0" i="0">
-                <a:solidFill>
-                  <a:srgbClr val="F5F5F5"/>
-                </a:solidFill>
-                <a:latin typeface="IBM Plex Sans Arabic"/>
-              </a:rPr>
-              <a:t>سيناريو رفض الحارس لتثبيت برنامج غير معتمد</a:t>
-            </a:r>
-          </a:p>
-        </p:txBody>
-      </p:sp>
-      <p:sp>
-        <p:nvSpPr>
-          <p:cNvPr id="13" name="TextBox 12"/>
-          <p:cNvSpPr txBox="1"/>
-          <p:nvPr/>
-        </p:nvSpPr>
-        <p:spPr>
-          <a:xfrm>
-            <a:off x="6505956" y="5257800"/>
-            <a:ext cx="4082796" cy="548640"/>
-          </a:xfrm>
-          <a:prstGeom prst="rect">
-            <a:avLst/>
-          </a:prstGeom>
-          <a:noFill/>
-        </p:spPr>
-        <p:txBody>
-          <a:bodyPr wrap="square" lIns="0" rIns="0" tIns="0" bIns="0" anchor="t">
-            <a:spAutoFit/>
-          </a:bodyPr>
-          <a:lstStyle/>
-          <a:p>
-            <a:pPr algn="r" rtl="1"/>
-            <a:r>
-              <a:rPr sz="1200" b="0" i="0">
-                <a:solidFill>
-                  <a:srgbClr val="FBBF24"/>
-                </a:solidFill>
-                <a:latin typeface="IBM Plex Sans Arabic"/>
-              </a:rPr>
-              <a:t>●  </a:t>
-            </a:r>
-            <a:r>
-              <a:rPr sz="1300" b="0" i="0">
-                <a:solidFill>
-                  <a:srgbClr val="F5F5F5"/>
-                </a:solidFill>
-                <a:latin typeface="IBM Plex Sans Arabic"/>
-              </a:rPr>
-              <a:t>ديمو يعمل من البداية للنهاية</a:t>
+              <a:t>بناء Agent Panel البصري</a:t>
             </a:r>
           </a:p>
         </p:txBody>
@@ -7702,8 +7693,8 @@
         </p:nvSpPr>
         <p:spPr>
           <a:xfrm>
-            <a:off x="1371600" y="1783080"/>
-            <a:ext cx="4539996" cy="4663440"/>
+            <a:off x="4322064" y="1691640"/>
+            <a:ext cx="3544824" cy="4754880"/>
           </a:xfrm>
           <a:prstGeom prst="roundRect">
             <a:avLst>
@@ -7749,8 +7740,423 @@
         </p:nvSpPr>
         <p:spPr>
           <a:xfrm>
-            <a:off x="1371600" y="1783080"/>
-            <a:ext cx="4539996" cy="54864"/>
+            <a:off x="4322064" y="1691640"/>
+            <a:ext cx="3544824" cy="54864"/>
+          </a:xfrm>
+          <a:prstGeom prst="rect">
+            <a:avLst/>
+          </a:prstGeom>
+          <a:solidFill>
+            <a:srgbClr val="4A9EFF"/>
+          </a:solidFill>
+          <a:ln>
+            <a:noFill/>
+          </a:ln>
+        </p:spPr>
+        <p:style>
+          <a:lnRef idx="1">
+            <a:schemeClr val="accent1"/>
+          </a:lnRef>
+          <a:fillRef idx="3">
+            <a:schemeClr val="accent1"/>
+          </a:fillRef>
+          <a:effectRef idx="2">
+            <a:schemeClr val="accent1"/>
+          </a:effectRef>
+          <a:fontRef idx="minor">
+            <a:schemeClr val="lt1"/>
+          </a:fontRef>
+        </p:style>
+        <p:txBody>
+          <a:bodyPr rtlCol="0" anchor="ctr"/>
+          <a:lstStyle/>
+          <a:p>
+            <a:pPr algn="ctr"/>
+          </a:p>
+        </p:txBody>
+      </p:sp>
+      <p:sp>
+        <p:nvSpPr>
+          <p:cNvPr id="16" name="TextBox 15"/>
+          <p:cNvSpPr txBox="1"/>
+          <p:nvPr/>
+        </p:nvSpPr>
+        <p:spPr>
+          <a:xfrm>
+            <a:off x="4523232" y="1892808"/>
+            <a:ext cx="3142488" cy="411480"/>
+          </a:xfrm>
+          <a:prstGeom prst="rect">
+            <a:avLst/>
+          </a:prstGeom>
+          <a:noFill/>
+        </p:spPr>
+        <p:txBody>
+          <a:bodyPr wrap="square" lIns="0" rIns="0" tIns="0" bIns="0" anchor="t">
+            <a:spAutoFit/>
+          </a:bodyPr>
+          <a:lstStyle/>
+          <a:p>
+            <a:pPr algn="r" rtl="1"/>
+            <a:r>
+              <a:rPr sz="1700" b="1" i="0">
+                <a:solidFill>
+                  <a:srgbClr val="4A9EFF"/>
+                </a:solidFill>
+                <a:latin typeface="IBM Plex Sans Arabic"/>
+              </a:rPr>
+              <a:t>خلال الهاكاثون</a:t>
+            </a:r>
+          </a:p>
+        </p:txBody>
+      </p:sp>
+      <p:sp>
+        <p:nvSpPr>
+          <p:cNvPr id="17" name="TextBox 16"/>
+          <p:cNvSpPr txBox="1"/>
+          <p:nvPr/>
+        </p:nvSpPr>
+        <p:spPr>
+          <a:xfrm>
+            <a:off x="4523232" y="2331720"/>
+            <a:ext cx="3142488" cy="274320"/>
+          </a:xfrm>
+          <a:prstGeom prst="rect">
+            <a:avLst/>
+          </a:prstGeom>
+          <a:noFill/>
+        </p:spPr>
+        <p:txBody>
+          <a:bodyPr wrap="square" lIns="0" rIns="0" tIns="0" bIns="0" anchor="t">
+            <a:spAutoFit/>
+          </a:bodyPr>
+          <a:lstStyle/>
+          <a:p>
+            <a:pPr algn="r"/>
+            <a:r>
+              <a:rPr sz="1100" b="0" i="0">
+                <a:solidFill>
+                  <a:srgbClr val="9CA3AF"/>
+                </a:solidFill>
+                <a:latin typeface="IBM Plex Sans Arabic"/>
+              </a:rPr>
+              <a:t>During (3 Days)</a:t>
+            </a:r>
+          </a:p>
+        </p:txBody>
+      </p:sp>
+      <p:sp>
+        <p:nvSpPr>
+          <p:cNvPr id="18" name="TextBox 17"/>
+          <p:cNvSpPr txBox="1"/>
+          <p:nvPr/>
+        </p:nvSpPr>
+        <p:spPr>
+          <a:xfrm>
+            <a:off x="4523232" y="2651760"/>
+            <a:ext cx="3142488" cy="320040"/>
+          </a:xfrm>
+          <a:prstGeom prst="rect">
+            <a:avLst/>
+          </a:prstGeom>
+          <a:noFill/>
+        </p:spPr>
+        <p:txBody>
+          <a:bodyPr wrap="square" lIns="0" rIns="0" tIns="0" bIns="0" anchor="t">
+            <a:spAutoFit/>
+          </a:bodyPr>
+          <a:lstStyle/>
+          <a:p>
+            <a:pPr algn="r" rtl="1"/>
+            <a:r>
+              <a:rPr sz="1200" b="1" i="0">
+                <a:solidFill>
+                  <a:srgbClr val="4A9EFF"/>
+                </a:solidFill>
+                <a:latin typeface="IBM Plex Sans Arabic"/>
+              </a:rPr>
+              <a:t>⏳  قيد التنفيذ</a:t>
+            </a:r>
+          </a:p>
+        </p:txBody>
+      </p:sp>
+      <p:sp>
+        <p:nvSpPr>
+          <p:cNvPr id="19" name="TextBox 18"/>
+          <p:cNvSpPr txBox="1"/>
+          <p:nvPr/>
+        </p:nvSpPr>
+        <p:spPr>
+          <a:xfrm>
+            <a:off x="4523232" y="3154680"/>
+            <a:ext cx="3142488" cy="548640"/>
+          </a:xfrm>
+          <a:prstGeom prst="rect">
+            <a:avLst/>
+          </a:prstGeom>
+          <a:noFill/>
+        </p:spPr>
+        <p:txBody>
+          <a:bodyPr wrap="square" lIns="0" rIns="0" tIns="0" bIns="0" anchor="t">
+            <a:spAutoFit/>
+          </a:bodyPr>
+          <a:lstStyle/>
+          <a:p>
+            <a:pPr algn="r" rtl="1"/>
+            <a:r>
+              <a:rPr sz="1100" b="0" i="0">
+                <a:solidFill>
+                  <a:srgbClr val="4A9EFF"/>
+                </a:solidFill>
+                <a:latin typeface="IBM Plex Sans Arabic"/>
+              </a:rPr>
+              <a:t>●  </a:t>
+            </a:r>
+            <a:r>
+              <a:rPr sz="1200" b="0" i="0">
+                <a:solidFill>
+                  <a:srgbClr val="F5F5F5"/>
+                </a:solidFill>
+                <a:latin typeface="IBM Plex Sans Arabic"/>
+              </a:rPr>
+              <a:t>تفعيل الوكلاء الأربعة بـ Claude API</a:t>
+            </a:r>
+          </a:p>
+        </p:txBody>
+      </p:sp>
+      <p:sp>
+        <p:nvSpPr>
+          <p:cNvPr id="20" name="TextBox 19"/>
+          <p:cNvSpPr txBox="1"/>
+          <p:nvPr/>
+        </p:nvSpPr>
+        <p:spPr>
+          <a:xfrm>
+            <a:off x="4523232" y="3703320"/>
+            <a:ext cx="3142488" cy="548640"/>
+          </a:xfrm>
+          <a:prstGeom prst="rect">
+            <a:avLst/>
+          </a:prstGeom>
+          <a:noFill/>
+        </p:spPr>
+        <p:txBody>
+          <a:bodyPr wrap="square" lIns="0" rIns="0" tIns="0" bIns="0" anchor="t">
+            <a:spAutoFit/>
+          </a:bodyPr>
+          <a:lstStyle/>
+          <a:p>
+            <a:pPr algn="r" rtl="1"/>
+            <a:r>
+              <a:rPr sz="1100" b="0" i="0">
+                <a:solidFill>
+                  <a:srgbClr val="4A9EFF"/>
+                </a:solidFill>
+                <a:latin typeface="IBM Plex Sans Arabic"/>
+              </a:rPr>
+              <a:t>●  </a:t>
+            </a:r>
+            <a:r>
+              <a:rPr sz="1200" b="0" i="0">
+                <a:solidFill>
+                  <a:srgbClr val="F5F5F5"/>
+                </a:solidFill>
+                <a:latin typeface="IBM Plex Sans Arabic"/>
+              </a:rPr>
+              <a:t>بناء طبقة RAG لقاعدة معرفة الشركة</a:t>
+            </a:r>
+          </a:p>
+        </p:txBody>
+      </p:sp>
+      <p:sp>
+        <p:nvSpPr>
+          <p:cNvPr id="21" name="TextBox 20"/>
+          <p:cNvSpPr txBox="1"/>
+          <p:nvPr/>
+        </p:nvSpPr>
+        <p:spPr>
+          <a:xfrm>
+            <a:off x="4523232" y="4251960"/>
+            <a:ext cx="3142488" cy="548640"/>
+          </a:xfrm>
+          <a:prstGeom prst="rect">
+            <a:avLst/>
+          </a:prstGeom>
+          <a:noFill/>
+        </p:spPr>
+        <p:txBody>
+          <a:bodyPr wrap="square" lIns="0" rIns="0" tIns="0" bIns="0" anchor="t">
+            <a:spAutoFit/>
+          </a:bodyPr>
+          <a:lstStyle/>
+          <a:p>
+            <a:pPr algn="r" rtl="1"/>
+            <a:r>
+              <a:rPr sz="1100" b="0" i="0">
+                <a:solidFill>
+                  <a:srgbClr val="4A9EFF"/>
+                </a:solidFill>
+                <a:latin typeface="IBM Plex Sans Arabic"/>
+              </a:rPr>
+              <a:t>●  </a:t>
+            </a:r>
+            <a:r>
+              <a:rPr sz="1200" b="0" i="0">
+                <a:solidFill>
+                  <a:srgbClr val="F5F5F5"/>
+                </a:solidFill>
+                <a:latin typeface="IBM Plex Sans Arabic"/>
+              </a:rPr>
+              <a:t>سيناريو اكتشاف الحوادث الجماعية</a:t>
+            </a:r>
+          </a:p>
+        </p:txBody>
+      </p:sp>
+      <p:sp>
+        <p:nvSpPr>
+          <p:cNvPr id="22" name="TextBox 21"/>
+          <p:cNvSpPr txBox="1"/>
+          <p:nvPr/>
+        </p:nvSpPr>
+        <p:spPr>
+          <a:xfrm>
+            <a:off x="4523232" y="4800600"/>
+            <a:ext cx="3142488" cy="548640"/>
+          </a:xfrm>
+          <a:prstGeom prst="rect">
+            <a:avLst/>
+          </a:prstGeom>
+          <a:noFill/>
+        </p:spPr>
+        <p:txBody>
+          <a:bodyPr wrap="square" lIns="0" rIns="0" tIns="0" bIns="0" anchor="t">
+            <a:spAutoFit/>
+          </a:bodyPr>
+          <a:lstStyle/>
+          <a:p>
+            <a:pPr algn="r" rtl="1"/>
+            <a:r>
+              <a:rPr sz="1100" b="0" i="0">
+                <a:solidFill>
+                  <a:srgbClr val="4A9EFF"/>
+                </a:solidFill>
+                <a:latin typeface="IBM Plex Sans Arabic"/>
+              </a:rPr>
+              <a:t>●  </a:t>
+            </a:r>
+            <a:r>
+              <a:rPr sz="1200" b="0" i="0">
+                <a:solidFill>
+                  <a:srgbClr val="F5F5F5"/>
+                </a:solidFill>
+                <a:latin typeface="IBM Plex Sans Arabic"/>
+              </a:rPr>
+              <a:t>سيناريو مراجعة Guardian</a:t>
+            </a:r>
+          </a:p>
+        </p:txBody>
+      </p:sp>
+      <p:sp>
+        <p:nvSpPr>
+          <p:cNvPr id="23" name="TextBox 22"/>
+          <p:cNvSpPr txBox="1"/>
+          <p:nvPr/>
+        </p:nvSpPr>
+        <p:spPr>
+          <a:xfrm>
+            <a:off x="4523232" y="5349240"/>
+            <a:ext cx="3142488" cy="548640"/>
+          </a:xfrm>
+          <a:prstGeom prst="rect">
+            <a:avLst/>
+          </a:prstGeom>
+          <a:noFill/>
+        </p:spPr>
+        <p:txBody>
+          <a:bodyPr wrap="square" lIns="0" rIns="0" tIns="0" bIns="0" anchor="t">
+            <a:spAutoFit/>
+          </a:bodyPr>
+          <a:lstStyle/>
+          <a:p>
+            <a:pPr algn="r" rtl="1"/>
+            <a:r>
+              <a:rPr sz="1100" b="0" i="0">
+                <a:solidFill>
+                  <a:srgbClr val="4A9EFF"/>
+                </a:solidFill>
+                <a:latin typeface="IBM Plex Sans Arabic"/>
+              </a:rPr>
+              <a:t>●  </a:t>
+            </a:r>
+            <a:r>
+              <a:rPr sz="1200" b="0" i="0">
+                <a:solidFill>
+                  <a:srgbClr val="F5F5F5"/>
+                </a:solidFill>
+                <a:latin typeface="IBM Plex Sans Arabic"/>
+              </a:rPr>
+              <a:t>ديمو شغّال end-to-end</a:t>
+            </a:r>
+          </a:p>
+        </p:txBody>
+      </p:sp>
+      <p:sp>
+        <p:nvSpPr>
+          <p:cNvPr id="24" name="Rounded Rectangle 23"/>
+          <p:cNvSpPr/>
+          <p:nvPr/>
+        </p:nvSpPr>
+        <p:spPr>
+          <a:xfrm>
+            <a:off x="548640" y="1691640"/>
+            <a:ext cx="3544824" cy="4754880"/>
+          </a:xfrm>
+          <a:prstGeom prst="roundRect">
+            <a:avLst>
+              <a:gd name="adj" fmla="val 4000"/>
+            </a:avLst>
+          </a:prstGeom>
+          <a:solidFill>
+            <a:srgbClr val="121212"/>
+          </a:solidFill>
+          <a:ln w="9525">
+            <a:solidFill>
+              <a:srgbClr val="1F1F1F"/>
+            </a:solidFill>
+          </a:ln>
+        </p:spPr>
+        <p:style>
+          <a:lnRef idx="1">
+            <a:schemeClr val="accent1"/>
+          </a:lnRef>
+          <a:fillRef idx="3">
+            <a:schemeClr val="accent1"/>
+          </a:fillRef>
+          <a:effectRef idx="2">
+            <a:schemeClr val="accent1"/>
+          </a:effectRef>
+          <a:fontRef idx="minor">
+            <a:schemeClr val="lt1"/>
+          </a:fontRef>
+        </p:style>
+        <p:txBody>
+          <a:bodyPr rtlCol="0" anchor="ctr"/>
+          <a:lstStyle/>
+          <a:p>
+            <a:pPr algn="ctr"/>
+          </a:p>
+        </p:txBody>
+      </p:sp>
+      <p:sp>
+        <p:nvSpPr>
+          <p:cNvPr id="25" name="Rectangle 24"/>
+          <p:cNvSpPr/>
+          <p:nvPr/>
+        </p:nvSpPr>
+        <p:spPr>
+          <a:xfrm>
+            <a:off x="548640" y="1691640"/>
+            <a:ext cx="3544824" cy="54864"/>
           </a:xfrm>
           <a:prstGeom prst="rect">
             <a:avLst/>
@@ -7786,14 +8192,14 @@
       </p:sp>
       <p:sp>
         <p:nvSpPr>
-          <p:cNvPr id="16" name="TextBox 15"/>
-          <p:cNvSpPr txBox="1"/>
-          <p:nvPr/>
-        </p:nvSpPr>
-        <p:spPr>
-          <a:xfrm>
-            <a:off x="1600200" y="2029968"/>
-            <a:ext cx="4082796" cy="457200"/>
+          <p:cNvPr id="26" name="TextBox 25"/>
+          <p:cNvSpPr txBox="1"/>
+          <p:nvPr/>
+        </p:nvSpPr>
+        <p:spPr>
+          <a:xfrm>
+            <a:off x="749808" y="1892808"/>
+            <a:ext cx="3142488" cy="411480"/>
           </a:xfrm>
           <a:prstGeom prst="rect">
             <a:avLst/>
@@ -7808,7 +8214,7 @@
           <a:p>
             <a:pPr algn="r" rtl="1"/>
             <a:r>
-              <a:rPr sz="1500" b="1" i="0">
+              <a:rPr sz="1700" b="1" i="0">
                 <a:solidFill>
                   <a:srgbClr val="9CA3AF"/>
                 </a:solidFill>
@@ -7821,14 +8227,14 @@
       </p:sp>
       <p:sp>
         <p:nvSpPr>
-          <p:cNvPr id="17" name="TextBox 16"/>
-          <p:cNvSpPr txBox="1"/>
-          <p:nvPr/>
-        </p:nvSpPr>
-        <p:spPr>
-          <a:xfrm>
-            <a:off x="1600200" y="2496312"/>
-            <a:ext cx="4082796" cy="292608"/>
+          <p:cNvPr id="27" name="TextBox 26"/>
+          <p:cNvSpPr txBox="1"/>
+          <p:nvPr/>
+        </p:nvSpPr>
+        <p:spPr>
+          <a:xfrm>
+            <a:off x="749808" y="2331720"/>
+            <a:ext cx="3142488" cy="274320"/>
           </a:xfrm>
           <a:prstGeom prst="rect">
             <a:avLst/>
@@ -7849,21 +8255,21 @@
                 </a:solidFill>
                 <a:latin typeface="IBM Plex Sans Arabic"/>
               </a:rPr>
-              <a:t>Beyond</a:t>
-            </a:r>
-          </a:p>
-        </p:txBody>
-      </p:sp>
-      <p:sp>
-        <p:nvSpPr>
-          <p:cNvPr id="18" name="TextBox 17"/>
-          <p:cNvSpPr txBox="1"/>
-          <p:nvPr/>
-        </p:nvSpPr>
-        <p:spPr>
-          <a:xfrm>
-            <a:off x="1600200" y="3063240"/>
-            <a:ext cx="4082796" cy="548640"/>
+              <a:t>After</a:t>
+            </a:r>
+          </a:p>
+        </p:txBody>
+      </p:sp>
+      <p:sp>
+        <p:nvSpPr>
+          <p:cNvPr id="28" name="TextBox 27"/>
+          <p:cNvSpPr txBox="1"/>
+          <p:nvPr/>
+        </p:nvSpPr>
+        <p:spPr>
+          <a:xfrm>
+            <a:off x="749808" y="2651760"/>
+            <a:ext cx="3142488" cy="320040"/>
           </a:xfrm>
           <a:prstGeom prst="rect">
             <a:avLst/>
@@ -7878,8 +8284,87 @@
           <a:p>
             <a:pPr algn="r" rtl="1"/>
             <a:r>
+              <a:rPr sz="1200" b="1" i="0">
+                <a:solidFill>
+                  <a:srgbClr val="9CA3AF"/>
+                </a:solidFill>
+                <a:latin typeface="IBM Plex Sans Arabic"/>
+              </a:rPr>
+              <a:t>🚀  مخطط</a:t>
+            </a:r>
+          </a:p>
+        </p:txBody>
+      </p:sp>
+      <p:sp>
+        <p:nvSpPr>
+          <p:cNvPr id="29" name="TextBox 28"/>
+          <p:cNvSpPr txBox="1"/>
+          <p:nvPr/>
+        </p:nvSpPr>
+        <p:spPr>
+          <a:xfrm>
+            <a:off x="749808" y="3154680"/>
+            <a:ext cx="3142488" cy="548640"/>
+          </a:xfrm>
+          <a:prstGeom prst="rect">
+            <a:avLst/>
+          </a:prstGeom>
+          <a:noFill/>
+        </p:spPr>
+        <p:txBody>
+          <a:bodyPr wrap="square" lIns="0" rIns="0" tIns="0" bIns="0" anchor="t">
+            <a:spAutoFit/>
+          </a:bodyPr>
+          <a:lstStyle/>
+          <a:p>
+            <a:pPr algn="r" rtl="1"/>
+            <a:r>
+              <a:rPr sz="1100" b="0" i="0">
+                <a:solidFill>
+                  <a:srgbClr val="9CA3AF"/>
+                </a:solidFill>
+                <a:latin typeface="IBM Plex Sans Arabic"/>
+              </a:rPr>
+              <a:t>●  </a:t>
+            </a:r>
+            <a:r>
               <a:rPr sz="1200" b="0" i="0">
                 <a:solidFill>
+                  <a:srgbClr val="F5F5F5"/>
+                </a:solidFill>
+                <a:latin typeface="IBM Plex Sans Arabic"/>
+              </a:rPr>
+              <a:t>Pilot مع شركة سعودية</a:t>
+            </a:r>
+          </a:p>
+        </p:txBody>
+      </p:sp>
+      <p:sp>
+        <p:nvSpPr>
+          <p:cNvPr id="30" name="TextBox 29"/>
+          <p:cNvSpPr txBox="1"/>
+          <p:nvPr/>
+        </p:nvSpPr>
+        <p:spPr>
+          <a:xfrm>
+            <a:off x="749808" y="3703320"/>
+            <a:ext cx="3142488" cy="548640"/>
+          </a:xfrm>
+          <a:prstGeom prst="rect">
+            <a:avLst/>
+          </a:prstGeom>
+          <a:noFill/>
+        </p:spPr>
+        <p:txBody>
+          <a:bodyPr wrap="square" lIns="0" rIns="0" tIns="0" bIns="0" anchor="t">
+            <a:spAutoFit/>
+          </a:bodyPr>
+          <a:lstStyle/>
+          <a:p>
+            <a:pPr algn="r" rtl="1"/>
+            <a:r>
+              <a:rPr sz="1100" b="0" i="0">
+                <a:solidFill>
                   <a:srgbClr val="9CA3AF"/>
                 </a:solidFill>
                 <a:latin typeface="IBM Plex Sans Arabic"/>
@@ -7887,27 +8372,27 @@
               <a:t>●  </a:t>
             </a:r>
             <a:r>
-              <a:rPr sz="1300" b="0" i="0">
+              <a:rPr sz="1200" b="0" i="0">
                 <a:solidFill>
                   <a:srgbClr val="F5F5F5"/>
                 </a:solidFill>
                 <a:latin typeface="IBM Plex Sans Arabic"/>
               </a:rPr>
-              <a:t>نشر تجريبي داخل شركة سعودية</a:t>
-            </a:r>
-          </a:p>
-        </p:txBody>
-      </p:sp>
-      <p:sp>
-        <p:nvSpPr>
-          <p:cNvPr id="19" name="TextBox 18"/>
-          <p:cNvSpPr txBox="1"/>
-          <p:nvPr/>
-        </p:nvSpPr>
-        <p:spPr>
-          <a:xfrm>
-            <a:off x="1600200" y="3611880"/>
-            <a:ext cx="4082796" cy="548640"/>
+              <a:t>تكامل مع Slack و Teams</a:t>
+            </a:r>
+          </a:p>
+        </p:txBody>
+      </p:sp>
+      <p:sp>
+        <p:nvSpPr>
+          <p:cNvPr id="31" name="TextBox 30"/>
+          <p:cNvSpPr txBox="1"/>
+          <p:nvPr/>
+        </p:nvSpPr>
+        <p:spPr>
+          <a:xfrm>
+            <a:off x="749808" y="4251960"/>
+            <a:ext cx="3142488" cy="548640"/>
           </a:xfrm>
           <a:prstGeom prst="rect">
             <a:avLst/>
@@ -7922,8 +8407,52 @@
           <a:p>
             <a:pPr algn="r" rtl="1"/>
             <a:r>
+              <a:rPr sz="1100" b="0" i="0">
+                <a:solidFill>
+                  <a:srgbClr val="9CA3AF"/>
+                </a:solidFill>
+                <a:latin typeface="IBM Plex Sans Arabic"/>
+              </a:rPr>
+              <a:t>●  </a:t>
+            </a:r>
+            <a:r>
               <a:rPr sz="1200" b="0" i="0">
                 <a:solidFill>
+                  <a:srgbClr val="F5F5F5"/>
+                </a:solidFill>
+                <a:latin typeface="IBM Plex Sans Arabic"/>
+              </a:rPr>
+              <a:t>لوحة تقارير NCA compliance</a:t>
+            </a:r>
+          </a:p>
+        </p:txBody>
+      </p:sp>
+      <p:sp>
+        <p:nvSpPr>
+          <p:cNvPr id="32" name="TextBox 31"/>
+          <p:cNvSpPr txBox="1"/>
+          <p:nvPr/>
+        </p:nvSpPr>
+        <p:spPr>
+          <a:xfrm>
+            <a:off x="749808" y="4800600"/>
+            <a:ext cx="3142488" cy="548640"/>
+          </a:xfrm>
+          <a:prstGeom prst="rect">
+            <a:avLst/>
+          </a:prstGeom>
+          <a:noFill/>
+        </p:spPr>
+        <p:txBody>
+          <a:bodyPr wrap="square" lIns="0" rIns="0" tIns="0" bIns="0" anchor="t">
+            <a:spAutoFit/>
+          </a:bodyPr>
+          <a:lstStyle/>
+          <a:p>
+            <a:pPr algn="r" rtl="1"/>
+            <a:r>
+              <a:rPr sz="1100" b="0" i="0">
+                <a:solidFill>
                   <a:srgbClr val="9CA3AF"/>
                 </a:solidFill>
                 <a:latin typeface="IBM Plex Sans Arabic"/>
@@ -7931,139 +8460,7 @@
               <a:t>●  </a:t>
             </a:r>
             <a:r>
-              <a:rPr sz="1300" b="0" i="0">
-                <a:solidFill>
-                  <a:srgbClr val="F5F5F5"/>
-                </a:solidFill>
-                <a:latin typeface="IBM Plex Sans Arabic"/>
-              </a:rPr>
-              <a:t>تكامل مع Slack و Teams و Email</a:t>
-            </a:r>
-          </a:p>
-        </p:txBody>
-      </p:sp>
-      <p:sp>
-        <p:nvSpPr>
-          <p:cNvPr id="20" name="TextBox 19"/>
-          <p:cNvSpPr txBox="1"/>
-          <p:nvPr/>
-        </p:nvSpPr>
-        <p:spPr>
-          <a:xfrm>
-            <a:off x="1600200" y="4160520"/>
-            <a:ext cx="4082796" cy="548640"/>
-          </a:xfrm>
-          <a:prstGeom prst="rect">
-            <a:avLst/>
-          </a:prstGeom>
-          <a:noFill/>
-        </p:spPr>
-        <p:txBody>
-          <a:bodyPr wrap="square" lIns="0" rIns="0" tIns="0" bIns="0" anchor="t">
-            <a:spAutoFit/>
-          </a:bodyPr>
-          <a:lstStyle/>
-          <a:p>
-            <a:pPr algn="r" rtl="1"/>
-            <a:r>
               <a:rPr sz="1200" b="0" i="0">
-                <a:solidFill>
-                  <a:srgbClr val="9CA3AF"/>
-                </a:solidFill>
-                <a:latin typeface="IBM Plex Sans Arabic"/>
-              </a:rPr>
-              <a:t>●  </a:t>
-            </a:r>
-            <a:r>
-              <a:rPr sz="1300" b="0" i="0">
-                <a:solidFill>
-                  <a:srgbClr val="F5F5F5"/>
-                </a:solidFill>
-                <a:latin typeface="IBM Plex Sans Arabic"/>
-              </a:rPr>
-              <a:t>لوحة امتثال NCA للمسؤول الأمني</a:t>
-            </a:r>
-          </a:p>
-        </p:txBody>
-      </p:sp>
-      <p:sp>
-        <p:nvSpPr>
-          <p:cNvPr id="21" name="TextBox 20"/>
-          <p:cNvSpPr txBox="1"/>
-          <p:nvPr/>
-        </p:nvSpPr>
-        <p:spPr>
-          <a:xfrm>
-            <a:off x="1600200" y="4709160"/>
-            <a:ext cx="4082796" cy="548640"/>
-          </a:xfrm>
-          <a:prstGeom prst="rect">
-            <a:avLst/>
-          </a:prstGeom>
-          <a:noFill/>
-        </p:spPr>
-        <p:txBody>
-          <a:bodyPr wrap="square" lIns="0" rIns="0" tIns="0" bIns="0" anchor="t">
-            <a:spAutoFit/>
-          </a:bodyPr>
-          <a:lstStyle/>
-          <a:p>
-            <a:pPr algn="r" rtl="1"/>
-            <a:r>
-              <a:rPr sz="1200" b="0" i="0">
-                <a:solidFill>
-                  <a:srgbClr val="9CA3AF"/>
-                </a:solidFill>
-                <a:latin typeface="IBM Plex Sans Arabic"/>
-              </a:rPr>
-              <a:t>●  </a:t>
-            </a:r>
-            <a:r>
-              <a:rPr sz="1300" b="0" i="0">
-                <a:solidFill>
-                  <a:srgbClr val="F5F5F5"/>
-                </a:solidFill>
-                <a:latin typeface="IBM Plex Sans Arabic"/>
-              </a:rPr>
-              <a:t>تحليلات للفريق التقني</a:t>
-            </a:r>
-          </a:p>
-        </p:txBody>
-      </p:sp>
-      <p:sp>
-        <p:nvSpPr>
-          <p:cNvPr id="22" name="TextBox 21"/>
-          <p:cNvSpPr txBox="1"/>
-          <p:nvPr/>
-        </p:nvSpPr>
-        <p:spPr>
-          <a:xfrm>
-            <a:off x="1600200" y="5257800"/>
-            <a:ext cx="4082796" cy="548640"/>
-          </a:xfrm>
-          <a:prstGeom prst="rect">
-            <a:avLst/>
-          </a:prstGeom>
-          <a:noFill/>
-        </p:spPr>
-        <p:txBody>
-          <a:bodyPr wrap="square" lIns="0" rIns="0" tIns="0" bIns="0" anchor="t">
-            <a:spAutoFit/>
-          </a:bodyPr>
-          <a:lstStyle/>
-          <a:p>
-            <a:pPr algn="r" rtl="1"/>
-            <a:r>
-              <a:rPr sz="1200" b="0" i="0">
-                <a:solidFill>
-                  <a:srgbClr val="9CA3AF"/>
-                </a:solidFill>
-                <a:latin typeface="IBM Plex Sans Arabic"/>
-              </a:rPr>
-              <a:t>●  </a:t>
-            </a:r>
-            <a:r>
-              <a:rPr sz="1300" b="0" i="0">
                 <a:solidFill>
                   <a:srgbClr val="F5F5F5"/>
                 </a:solidFill>

</xml_diff>

<commit_message>
Multi-agent IT Assistant: 3-agent architecture
- Resolver: real Anthropic Computer Use loop (works on macOS)
- Memory: real Claude Agent SDK call with searchPastTickets tool over
  12 seeded Arabic tickets covering Outlook, network, Slack, password
- Guardian: real Claude Agent SDK call with lookupPolicy tool over
  7 NCA policy snippets, returns approve/block/escalate plus alternative
- Scripted tools: openApp, quitApp, restartApp, switchWifi for fast
  known-pattern resolution (~1s vs 15-30s for Computer Use)
- Agent panel pulses blue with "🛑 الوكيل يعمل — لا تحرّك المؤشر"
  during Computer Use to prevent user interruption
- PTT lock: rejects new presses while a turn is mid-processing
- Standalone test scripts (test-memory.mjs, test-guardian.mjs) so
  Memory + Guardian can be iterated on Windows without running Flicky

Co-Authored-By: Claude Opus 4.7 (1M context) <noreply@anthropic.com>
</commit_message>
<xml_diff>
--- a/docs/pitch-deck.pptx
+++ b/docs/pitch-deck.pptx
@@ -5,15 +5,15 @@
     <p:sldMasterId id="2147483648" r:id="rId1"/>
   </p:sldMasterIdLst>
   <p:sldIdLst>
-    <p:sldId id="256" r:id="rId7"/>
-    <p:sldId id="257" r:id="rId8"/>
-    <p:sldId id="258" r:id="rId9"/>
-    <p:sldId id="259" r:id="rId10"/>
-    <p:sldId id="260" r:id="rId11"/>
-    <p:sldId id="261" r:id="rId12"/>
-    <p:sldId id="262" r:id="rId13"/>
+    <p:sldId id="256" r:id="rId2"/>
+    <p:sldId id="257" r:id="rId3"/>
+    <p:sldId id="258" r:id="rId4"/>
+    <p:sldId id="259" r:id="rId5"/>
+    <p:sldId id="260" r:id="rId6"/>
+    <p:sldId id="261" r:id="rId7"/>
+    <p:sldId id="262" r:id="rId8"/>
   </p:sldIdLst>
-  <p:sldSz cx="12188952" cy="6858000" type="screen4x3"/>
+  <p:sldSz cx="12188825" cy="6858000"/>
   <p:notesSz cx="6858000" cy="9144000"/>
   <p:defaultTextStyle>
     <a:defPPr>
@@ -110,6 +110,22 @@
       </a:defRPr>
     </a:lvl9pPr>
   </p:defaultTextStyle>
+  <p:extLst>
+    <p:ext uri="{EFAFB233-063F-42B5-8137-9DF3F51BA10A}">
+      <p15:sldGuideLst xmlns:p15="http://schemas.microsoft.com/office/powerpoint/2012/main">
+        <p15:guide id="1" orient="horz" pos="2160">
+          <p15:clr>
+            <a:srgbClr val="A4A3A4"/>
+          </p15:clr>
+        </p15:guide>
+        <p15:guide id="2" pos="2880">
+          <p15:clr>
+            <a:srgbClr val="A4A3A4"/>
+          </p15:clr>
+        </p15:guide>
+      </p15:sldGuideLst>
+    </p:ext>
+  </p:extLst>
 </p:presentation>
 </file>
 
@@ -151,10 +167,9 @@
           <a:lstStyle/>
           <a:p>
             <a:r>
-              <a:rPr lang="en-US" smtClean="0"/>
+              <a:rPr lang="en-US"/>
               <a:t>Click to edit Master title style</a:t>
             </a:r>
-            <a:endParaRPr lang="en-US"/>
           </a:p>
         </p:txBody>
       </p:sp>
@@ -270,10 +285,9 @@
           </a:lstStyle>
           <a:p>
             <a:r>
-              <a:rPr lang="en-US" smtClean="0"/>
+              <a:rPr lang="en-US"/>
               <a:t>Click to edit Master subtitle style</a:t>
             </a:r>
-            <a:endParaRPr lang="en-US"/>
           </a:p>
         </p:txBody>
       </p:sp>
@@ -294,7 +308,7 @@
           <a:p>
             <a:fld id="{5BCAD085-E8A6-8845-BD4E-CB4CCA059FC4}" type="datetimeFigureOut">
               <a:rPr lang="en-US" smtClean="0"/>
-              <a:t>1/27/13</a:t>
+              <a:t>4/26/26</a:t>
             </a:fld>
             <a:endParaRPr lang="en-US"/>
           </a:p>
@@ -388,10 +402,9 @@
           <a:lstStyle/>
           <a:p>
             <a:r>
-              <a:rPr lang="en-US" smtClean="0"/>
+              <a:rPr lang="en-US"/>
               <a:t>Click to edit Master title style</a:t>
             </a:r>
-            <a:endParaRPr lang="en-US"/>
           </a:p>
         </p:txBody>
       </p:sp>
@@ -412,38 +425,37 @@
           <a:p>
             <a:pPr lvl="0"/>
             <a:r>
-              <a:rPr lang="en-US" smtClean="0"/>
+              <a:rPr lang="en-US"/>
               <a:t>Click to edit Master text styles</a:t>
             </a:r>
           </a:p>
           <a:p>
             <a:pPr lvl="1"/>
             <a:r>
-              <a:rPr lang="en-US" smtClean="0"/>
+              <a:rPr lang="en-US"/>
               <a:t>Second level</a:t>
             </a:r>
           </a:p>
           <a:p>
             <a:pPr lvl="2"/>
             <a:r>
-              <a:rPr lang="en-US" smtClean="0"/>
+              <a:rPr lang="en-US"/>
               <a:t>Third level</a:t>
             </a:r>
           </a:p>
           <a:p>
             <a:pPr lvl="3"/>
             <a:r>
-              <a:rPr lang="en-US" smtClean="0"/>
+              <a:rPr lang="en-US"/>
               <a:t>Fourth level</a:t>
             </a:r>
           </a:p>
           <a:p>
             <a:pPr lvl="4"/>
             <a:r>
-              <a:rPr lang="en-US" smtClean="0"/>
+              <a:rPr lang="en-US"/>
               <a:t>Fifth level</a:t>
             </a:r>
-            <a:endParaRPr lang="en-US"/>
           </a:p>
         </p:txBody>
       </p:sp>
@@ -464,7 +476,7 @@
           <a:p>
             <a:fld id="{5BCAD085-E8A6-8845-BD4E-CB4CCA059FC4}" type="datetimeFigureOut">
               <a:rPr lang="en-US" smtClean="0"/>
-              <a:t>1/27/13</a:t>
+              <a:t>4/26/26</a:t>
             </a:fld>
             <a:endParaRPr lang="en-US"/>
           </a:p>
@@ -563,10 +575,9 @@
           <a:lstStyle/>
           <a:p>
             <a:r>
-              <a:rPr lang="en-US" smtClean="0"/>
+              <a:rPr lang="en-US"/>
               <a:t>Click to edit Master title style</a:t>
             </a:r>
-            <a:endParaRPr lang="en-US"/>
           </a:p>
         </p:txBody>
       </p:sp>
@@ -592,38 +603,37 @@
           <a:p>
             <a:pPr lvl="0"/>
             <a:r>
-              <a:rPr lang="en-US" smtClean="0"/>
+              <a:rPr lang="en-US"/>
               <a:t>Click to edit Master text styles</a:t>
             </a:r>
           </a:p>
           <a:p>
             <a:pPr lvl="1"/>
             <a:r>
-              <a:rPr lang="en-US" smtClean="0"/>
+              <a:rPr lang="en-US"/>
               <a:t>Second level</a:t>
             </a:r>
           </a:p>
           <a:p>
             <a:pPr lvl="2"/>
             <a:r>
-              <a:rPr lang="en-US" smtClean="0"/>
+              <a:rPr lang="en-US"/>
               <a:t>Third level</a:t>
             </a:r>
           </a:p>
           <a:p>
             <a:pPr lvl="3"/>
             <a:r>
-              <a:rPr lang="en-US" smtClean="0"/>
+              <a:rPr lang="en-US"/>
               <a:t>Fourth level</a:t>
             </a:r>
           </a:p>
           <a:p>
             <a:pPr lvl="4"/>
             <a:r>
-              <a:rPr lang="en-US" smtClean="0"/>
+              <a:rPr lang="en-US"/>
               <a:t>Fifth level</a:t>
             </a:r>
-            <a:endParaRPr lang="en-US"/>
           </a:p>
         </p:txBody>
       </p:sp>
@@ -644,7 +654,7 @@
           <a:p>
             <a:fld id="{5BCAD085-E8A6-8845-BD4E-CB4CCA059FC4}" type="datetimeFigureOut">
               <a:rPr lang="en-US" smtClean="0"/>
-              <a:t>1/27/13</a:t>
+              <a:t>4/26/26</a:t>
             </a:fld>
             <a:endParaRPr lang="en-US"/>
           </a:p>
@@ -738,10 +748,9 @@
           <a:lstStyle/>
           <a:p>
             <a:r>
-              <a:rPr lang="en-US" smtClean="0"/>
+              <a:rPr lang="en-US"/>
               <a:t>Click to edit Master title style</a:t>
             </a:r>
-            <a:endParaRPr lang="en-US"/>
           </a:p>
         </p:txBody>
       </p:sp>
@@ -762,38 +771,37 @@
           <a:p>
             <a:pPr lvl="0"/>
             <a:r>
-              <a:rPr lang="en-US" smtClean="0"/>
+              <a:rPr lang="en-US"/>
               <a:t>Click to edit Master text styles</a:t>
             </a:r>
           </a:p>
           <a:p>
             <a:pPr lvl="1"/>
             <a:r>
-              <a:rPr lang="en-US" smtClean="0"/>
+              <a:rPr lang="en-US"/>
               <a:t>Second level</a:t>
             </a:r>
           </a:p>
           <a:p>
             <a:pPr lvl="2"/>
             <a:r>
-              <a:rPr lang="en-US" smtClean="0"/>
+              <a:rPr lang="en-US"/>
               <a:t>Third level</a:t>
             </a:r>
           </a:p>
           <a:p>
             <a:pPr lvl="3"/>
             <a:r>
-              <a:rPr lang="en-US" smtClean="0"/>
+              <a:rPr lang="en-US"/>
               <a:t>Fourth level</a:t>
             </a:r>
           </a:p>
           <a:p>
             <a:pPr lvl="4"/>
             <a:r>
-              <a:rPr lang="en-US" smtClean="0"/>
+              <a:rPr lang="en-US"/>
               <a:t>Fifth level</a:t>
             </a:r>
-            <a:endParaRPr lang="en-US"/>
           </a:p>
         </p:txBody>
       </p:sp>
@@ -814,7 +822,7 @@
           <a:p>
             <a:fld id="{5BCAD085-E8A6-8845-BD4E-CB4CCA059FC4}" type="datetimeFigureOut">
               <a:rPr lang="en-US" smtClean="0"/>
-              <a:t>1/27/13</a:t>
+              <a:t>4/26/26</a:t>
             </a:fld>
             <a:endParaRPr lang="en-US"/>
           </a:p>
@@ -917,10 +925,9 @@
           </a:lstStyle>
           <a:p>
             <a:r>
-              <a:rPr lang="en-US" smtClean="0"/>
+              <a:rPr lang="en-US"/>
               <a:t>Click to edit Master title style</a:t>
             </a:r>
-            <a:endParaRPr lang="en-US"/>
           </a:p>
         </p:txBody>
       </p:sp>
@@ -1037,7 +1044,7 @@
           <a:p>
             <a:pPr lvl="0"/>
             <a:r>
-              <a:rPr lang="en-US" smtClean="0"/>
+              <a:rPr lang="en-US"/>
               <a:t>Click to edit Master text styles</a:t>
             </a:r>
           </a:p>
@@ -1060,7 +1067,7 @@
           <a:p>
             <a:fld id="{5BCAD085-E8A6-8845-BD4E-CB4CCA059FC4}" type="datetimeFigureOut">
               <a:rPr lang="en-US" smtClean="0"/>
-              <a:t>1/27/13</a:t>
+              <a:t>4/26/26</a:t>
             </a:fld>
             <a:endParaRPr lang="en-US"/>
           </a:p>
@@ -1154,10 +1161,9 @@
           <a:lstStyle/>
           <a:p>
             <a:r>
-              <a:rPr lang="en-US" smtClean="0"/>
+              <a:rPr lang="en-US"/>
               <a:t>Click to edit Master title style</a:t>
             </a:r>
-            <a:endParaRPr lang="en-US"/>
           </a:p>
         </p:txBody>
       </p:sp>
@@ -1211,38 +1217,37 @@
           <a:p>
             <a:pPr lvl="0"/>
             <a:r>
-              <a:rPr lang="en-US" smtClean="0"/>
+              <a:rPr lang="en-US"/>
               <a:t>Click to edit Master text styles</a:t>
             </a:r>
           </a:p>
           <a:p>
             <a:pPr lvl="1"/>
             <a:r>
-              <a:rPr lang="en-US" smtClean="0"/>
+              <a:rPr lang="en-US"/>
               <a:t>Second level</a:t>
             </a:r>
           </a:p>
           <a:p>
             <a:pPr lvl="2"/>
             <a:r>
-              <a:rPr lang="en-US" smtClean="0"/>
+              <a:rPr lang="en-US"/>
               <a:t>Third level</a:t>
             </a:r>
           </a:p>
           <a:p>
             <a:pPr lvl="3"/>
             <a:r>
-              <a:rPr lang="en-US" smtClean="0"/>
+              <a:rPr lang="en-US"/>
               <a:t>Fourth level</a:t>
             </a:r>
           </a:p>
           <a:p>
             <a:pPr lvl="4"/>
             <a:r>
-              <a:rPr lang="en-US" smtClean="0"/>
+              <a:rPr lang="en-US"/>
               <a:t>Fifth level</a:t>
             </a:r>
-            <a:endParaRPr lang="en-US"/>
           </a:p>
         </p:txBody>
       </p:sp>
@@ -1296,38 +1301,37 @@
           <a:p>
             <a:pPr lvl="0"/>
             <a:r>
-              <a:rPr lang="en-US" smtClean="0"/>
+              <a:rPr lang="en-US"/>
               <a:t>Click to edit Master text styles</a:t>
             </a:r>
           </a:p>
           <a:p>
             <a:pPr lvl="1"/>
             <a:r>
-              <a:rPr lang="en-US" smtClean="0"/>
+              <a:rPr lang="en-US"/>
               <a:t>Second level</a:t>
             </a:r>
           </a:p>
           <a:p>
             <a:pPr lvl="2"/>
             <a:r>
-              <a:rPr lang="en-US" smtClean="0"/>
+              <a:rPr lang="en-US"/>
               <a:t>Third level</a:t>
             </a:r>
           </a:p>
           <a:p>
             <a:pPr lvl="3"/>
             <a:r>
-              <a:rPr lang="en-US" smtClean="0"/>
+              <a:rPr lang="en-US"/>
               <a:t>Fourth level</a:t>
             </a:r>
           </a:p>
           <a:p>
             <a:pPr lvl="4"/>
             <a:r>
-              <a:rPr lang="en-US" smtClean="0"/>
+              <a:rPr lang="en-US"/>
               <a:t>Fifth level</a:t>
             </a:r>
-            <a:endParaRPr lang="en-US"/>
           </a:p>
         </p:txBody>
       </p:sp>
@@ -1348,7 +1352,7 @@
           <a:p>
             <a:fld id="{5BCAD085-E8A6-8845-BD4E-CB4CCA059FC4}" type="datetimeFigureOut">
               <a:rPr lang="en-US" smtClean="0"/>
-              <a:t>1/27/13</a:t>
+              <a:t>4/26/26</a:t>
             </a:fld>
             <a:endParaRPr lang="en-US"/>
           </a:p>
@@ -1446,10 +1450,9 @@
           </a:lstStyle>
           <a:p>
             <a:r>
-              <a:rPr lang="en-US" smtClean="0"/>
+              <a:rPr lang="en-US"/>
               <a:t>Click to edit Master title style</a:t>
             </a:r>
-            <a:endParaRPr lang="en-US"/>
           </a:p>
         </p:txBody>
       </p:sp>
@@ -1512,7 +1515,7 @@
           <a:p>
             <a:pPr lvl="0"/>
             <a:r>
-              <a:rPr lang="en-US" smtClean="0"/>
+              <a:rPr lang="en-US"/>
               <a:t>Click to edit Master text styles</a:t>
             </a:r>
           </a:p>
@@ -1568,38 +1571,37 @@
           <a:p>
             <a:pPr lvl="0"/>
             <a:r>
-              <a:rPr lang="en-US" smtClean="0"/>
+              <a:rPr lang="en-US"/>
               <a:t>Click to edit Master text styles</a:t>
             </a:r>
           </a:p>
           <a:p>
             <a:pPr lvl="1"/>
             <a:r>
-              <a:rPr lang="en-US" smtClean="0"/>
+              <a:rPr lang="en-US"/>
               <a:t>Second level</a:t>
             </a:r>
           </a:p>
           <a:p>
             <a:pPr lvl="2"/>
             <a:r>
-              <a:rPr lang="en-US" smtClean="0"/>
+              <a:rPr lang="en-US"/>
               <a:t>Third level</a:t>
             </a:r>
           </a:p>
           <a:p>
             <a:pPr lvl="3"/>
             <a:r>
-              <a:rPr lang="en-US" smtClean="0"/>
+              <a:rPr lang="en-US"/>
               <a:t>Fourth level</a:t>
             </a:r>
           </a:p>
           <a:p>
             <a:pPr lvl="4"/>
             <a:r>
-              <a:rPr lang="en-US" smtClean="0"/>
+              <a:rPr lang="en-US"/>
               <a:t>Fifth level</a:t>
             </a:r>
-            <a:endParaRPr lang="en-US"/>
           </a:p>
         </p:txBody>
       </p:sp>
@@ -1662,7 +1664,7 @@
           <a:p>
             <a:pPr lvl="0"/>
             <a:r>
-              <a:rPr lang="en-US" smtClean="0"/>
+              <a:rPr lang="en-US"/>
               <a:t>Click to edit Master text styles</a:t>
             </a:r>
           </a:p>
@@ -1718,38 +1720,37 @@
           <a:p>
             <a:pPr lvl="0"/>
             <a:r>
-              <a:rPr lang="en-US" smtClean="0"/>
+              <a:rPr lang="en-US"/>
               <a:t>Click to edit Master text styles</a:t>
             </a:r>
           </a:p>
           <a:p>
             <a:pPr lvl="1"/>
             <a:r>
-              <a:rPr lang="en-US" smtClean="0"/>
+              <a:rPr lang="en-US"/>
               <a:t>Second level</a:t>
             </a:r>
           </a:p>
           <a:p>
             <a:pPr lvl="2"/>
             <a:r>
-              <a:rPr lang="en-US" smtClean="0"/>
+              <a:rPr lang="en-US"/>
               <a:t>Third level</a:t>
             </a:r>
           </a:p>
           <a:p>
             <a:pPr lvl="3"/>
             <a:r>
-              <a:rPr lang="en-US" smtClean="0"/>
+              <a:rPr lang="en-US"/>
               <a:t>Fourth level</a:t>
             </a:r>
           </a:p>
           <a:p>
             <a:pPr lvl="4"/>
             <a:r>
-              <a:rPr lang="en-US" smtClean="0"/>
+              <a:rPr lang="en-US"/>
               <a:t>Fifth level</a:t>
             </a:r>
-            <a:endParaRPr lang="en-US"/>
           </a:p>
         </p:txBody>
       </p:sp>
@@ -1770,7 +1771,7 @@
           <a:p>
             <a:fld id="{5BCAD085-E8A6-8845-BD4E-CB4CCA059FC4}" type="datetimeFigureOut">
               <a:rPr lang="en-US" smtClean="0"/>
-              <a:t>1/27/13</a:t>
+              <a:t>4/26/26</a:t>
             </a:fld>
             <a:endParaRPr lang="en-US"/>
           </a:p>
@@ -1864,10 +1865,9 @@
           <a:lstStyle/>
           <a:p>
             <a:r>
-              <a:rPr lang="en-US" smtClean="0"/>
+              <a:rPr lang="en-US"/>
               <a:t>Click to edit Master title style</a:t>
             </a:r>
-            <a:endParaRPr lang="en-US"/>
           </a:p>
         </p:txBody>
       </p:sp>
@@ -1888,7 +1888,7 @@
           <a:p>
             <a:fld id="{5BCAD085-E8A6-8845-BD4E-CB4CCA059FC4}" type="datetimeFigureOut">
               <a:rPr lang="en-US" smtClean="0"/>
-              <a:t>1/27/13</a:t>
+              <a:t>4/26/26</a:t>
             </a:fld>
             <a:endParaRPr lang="en-US"/>
           </a:p>
@@ -1983,7 +1983,7 @@
           <a:p>
             <a:fld id="{5BCAD085-E8A6-8845-BD4E-CB4CCA059FC4}" type="datetimeFigureOut">
               <a:rPr lang="en-US" smtClean="0"/>
-              <a:t>1/27/13</a:t>
+              <a:t>4/26/26</a:t>
             </a:fld>
             <a:endParaRPr lang="en-US"/>
           </a:p>
@@ -2086,10 +2086,9 @@
           </a:lstStyle>
           <a:p>
             <a:r>
-              <a:rPr lang="en-US" smtClean="0"/>
+              <a:rPr lang="en-US"/>
               <a:t>Click to edit Master title style</a:t>
             </a:r>
-            <a:endParaRPr lang="en-US"/>
           </a:p>
         </p:txBody>
       </p:sp>
@@ -2143,38 +2142,37 @@
           <a:p>
             <a:pPr lvl="0"/>
             <a:r>
-              <a:rPr lang="en-US" smtClean="0"/>
+              <a:rPr lang="en-US"/>
               <a:t>Click to edit Master text styles</a:t>
             </a:r>
           </a:p>
           <a:p>
             <a:pPr lvl="1"/>
             <a:r>
-              <a:rPr lang="en-US" smtClean="0"/>
+              <a:rPr lang="en-US"/>
               <a:t>Second level</a:t>
             </a:r>
           </a:p>
           <a:p>
             <a:pPr lvl="2"/>
             <a:r>
-              <a:rPr lang="en-US" smtClean="0"/>
+              <a:rPr lang="en-US"/>
               <a:t>Third level</a:t>
             </a:r>
           </a:p>
           <a:p>
             <a:pPr lvl="3"/>
             <a:r>
-              <a:rPr lang="en-US" smtClean="0"/>
+              <a:rPr lang="en-US"/>
               <a:t>Fourth level</a:t>
             </a:r>
           </a:p>
           <a:p>
             <a:pPr lvl="4"/>
             <a:r>
-              <a:rPr lang="en-US" smtClean="0"/>
+              <a:rPr lang="en-US"/>
               <a:t>Fifth level</a:t>
             </a:r>
-            <a:endParaRPr lang="en-US"/>
           </a:p>
         </p:txBody>
       </p:sp>
@@ -2237,7 +2235,7 @@
           <a:p>
             <a:pPr lvl="0"/>
             <a:r>
-              <a:rPr lang="en-US" smtClean="0"/>
+              <a:rPr lang="en-US"/>
               <a:t>Click to edit Master text styles</a:t>
             </a:r>
           </a:p>
@@ -2260,7 +2258,7 @@
           <a:p>
             <a:fld id="{5BCAD085-E8A6-8845-BD4E-CB4CCA059FC4}" type="datetimeFigureOut">
               <a:rPr lang="en-US" smtClean="0"/>
-              <a:t>1/27/13</a:t>
+              <a:t>4/26/26</a:t>
             </a:fld>
             <a:endParaRPr lang="en-US"/>
           </a:p>
@@ -2363,10 +2361,9 @@
           </a:lstStyle>
           <a:p>
             <a:r>
-              <a:rPr lang="en-US" smtClean="0"/>
+              <a:rPr lang="en-US"/>
               <a:t>Click to edit Master title style</a:t>
             </a:r>
-            <a:endParaRPr lang="en-US"/>
           </a:p>
         </p:txBody>
       </p:sp>
@@ -2490,7 +2487,7 @@
           <a:p>
             <a:pPr lvl="0"/>
             <a:r>
-              <a:rPr lang="en-US" smtClean="0"/>
+              <a:rPr lang="en-US"/>
               <a:t>Click to edit Master text styles</a:t>
             </a:r>
           </a:p>
@@ -2513,7 +2510,7 @@
           <a:p>
             <a:fld id="{5BCAD085-E8A6-8845-BD4E-CB4CCA059FC4}" type="datetimeFigureOut">
               <a:rPr lang="en-US" smtClean="0"/>
-              <a:t>1/27/13</a:t>
+              <a:t>4/26/26</a:t>
             </a:fld>
             <a:endParaRPr lang="en-US"/>
           </a:p>
@@ -2622,10 +2619,9 @@
           <a:lstStyle/>
           <a:p>
             <a:r>
-              <a:rPr lang="en-US" smtClean="0"/>
+              <a:rPr lang="en-US"/>
               <a:t>Click to edit Master title style</a:t>
             </a:r>
-            <a:endParaRPr lang="en-US"/>
           </a:p>
         </p:txBody>
       </p:sp>
@@ -2656,38 +2652,37 @@
           <a:p>
             <a:pPr lvl="0"/>
             <a:r>
-              <a:rPr lang="en-US" smtClean="0"/>
+              <a:rPr lang="en-US"/>
               <a:t>Click to edit Master text styles</a:t>
             </a:r>
           </a:p>
           <a:p>
             <a:pPr lvl="1"/>
             <a:r>
-              <a:rPr lang="en-US" smtClean="0"/>
+              <a:rPr lang="en-US"/>
               <a:t>Second level</a:t>
             </a:r>
           </a:p>
           <a:p>
             <a:pPr lvl="2"/>
             <a:r>
-              <a:rPr lang="en-US" smtClean="0"/>
+              <a:rPr lang="en-US"/>
               <a:t>Third level</a:t>
             </a:r>
           </a:p>
           <a:p>
             <a:pPr lvl="3"/>
             <a:r>
-              <a:rPr lang="en-US" smtClean="0"/>
+              <a:rPr lang="en-US"/>
               <a:t>Fourth level</a:t>
             </a:r>
           </a:p>
           <a:p>
             <a:pPr lvl="4"/>
             <a:r>
-              <a:rPr lang="en-US" smtClean="0"/>
+              <a:rPr lang="en-US"/>
               <a:t>Fifth level</a:t>
             </a:r>
-            <a:endParaRPr lang="en-US"/>
           </a:p>
         </p:txBody>
       </p:sp>
@@ -2726,7 +2721,7 @@
           <a:p>
             <a:fld id="{5BCAD085-E8A6-8845-BD4E-CB4CCA059FC4}" type="datetimeFigureOut">
               <a:rPr lang="en-US" smtClean="0"/>
-              <a:t>1/27/13</a:t>
+              <a:t>4/26/26</a:t>
             </a:fld>
             <a:endParaRPr lang="en-US"/>
           </a:p>
@@ -3085,7 +3080,7 @@
 </file>
 
 <file path=ppt/slides/slide1.xml><?xml version="1.0" encoding="utf-8"?>
-<p:sld xmlns:a="http://schemas.openxmlformats.org/drawingml/2006/main" xmlns:p="http://schemas.openxmlformats.org/presentationml/2006/main" xmlns:r="http://schemas.openxmlformats.org/officeDocument/2006/relationships">
+<p:sld xmlns:a="http://schemas.openxmlformats.org/drawingml/2006/main" xmlns:r="http://schemas.openxmlformats.org/officeDocument/2006/relationships" xmlns:p="http://schemas.openxmlformats.org/presentationml/2006/main">
   <p:cSld>
     <p:spTree>
       <p:nvGrpSpPr>
@@ -3093,7 +3088,14 @@
         <p:cNvGrpSpPr/>
         <p:nvPr/>
       </p:nvGrpSpPr>
-      <p:grpSpPr/>
+      <p:grpSpPr>
+        <a:xfrm>
+          <a:off x="0" y="0"/>
+          <a:ext cx="0" cy="0"/>
+          <a:chOff x="0" y="0"/>
+          <a:chExt cx="0" cy="0"/>
+        </a:xfrm>
+      </p:grpSpPr>
       <p:sp>
         <p:nvSpPr>
           <p:cNvPr id="2" name="Rectangle 1"/>
@@ -3134,6 +3136,7 @@
           <a:lstStyle/>
           <a:p>
             <a:pPr algn="ctr"/>
+            <a:endParaRPr/>
           </a:p>
         </p:txBody>
       </p:sp>
@@ -3154,7 +3157,7 @@
           <a:noFill/>
         </p:spPr>
         <p:txBody>
-          <a:bodyPr wrap="square" lIns="0" rIns="0" tIns="0" bIns="0" anchor="t">
+          <a:bodyPr wrap="square" lIns="0" tIns="0" rIns="0" bIns="0" anchor="t">
             <a:spAutoFit/>
           </a:bodyPr>
           <a:lstStyle/>
@@ -3189,7 +3192,7 @@
           <a:noFill/>
         </p:spPr>
         <p:txBody>
-          <a:bodyPr wrap="square" lIns="0" rIns="0" tIns="0" bIns="0" anchor="t">
+          <a:bodyPr wrap="square" lIns="0" tIns="0" rIns="0" bIns="0" anchor="t">
             <a:spAutoFit/>
           </a:bodyPr>
           <a:lstStyle/>
@@ -3224,7 +3227,7 @@
           <a:noFill/>
         </p:spPr>
         <p:txBody>
-          <a:bodyPr wrap="square" lIns="0" rIns="0" tIns="0" bIns="0" anchor="t">
+          <a:bodyPr wrap="square" lIns="0" tIns="0" rIns="0" bIns="0" anchor="t">
             <a:spAutoFit/>
           </a:bodyPr>
           <a:lstStyle/>
@@ -3259,7 +3262,7 @@
           <a:noFill/>
         </p:spPr>
         <p:txBody>
-          <a:bodyPr wrap="square" lIns="0" rIns="0" tIns="0" bIns="0" anchor="t">
+          <a:bodyPr wrap="square" lIns="0" tIns="0" rIns="0" bIns="0" anchor="t">
             <a:spAutoFit/>
           </a:bodyPr>
           <a:lstStyle/>
@@ -3294,7 +3297,7 @@
           <a:noFill/>
         </p:spPr>
         <p:txBody>
-          <a:bodyPr wrap="square" lIns="0" rIns="0" tIns="0" bIns="0" anchor="t">
+          <a:bodyPr wrap="square" lIns="0" tIns="0" rIns="0" bIns="0" anchor="t">
             <a:spAutoFit/>
           </a:bodyPr>
           <a:lstStyle/>
@@ -3387,6 +3390,7 @@
           <a:lstStyle/>
           <a:p>
             <a:pPr algn="ctr"/>
+            <a:endParaRPr/>
           </a:p>
         </p:txBody>
       </p:sp>
@@ -3430,6 +3434,7 @@
           <a:lstStyle/>
           <a:p>
             <a:pPr algn="ctr"/>
+            <a:endParaRPr/>
           </a:p>
         </p:txBody>
       </p:sp>
@@ -3473,6 +3478,7 @@
           <a:lstStyle/>
           <a:p>
             <a:pPr algn="ctr"/>
+            <a:endParaRPr/>
           </a:p>
         </p:txBody>
       </p:sp>
@@ -3516,6 +3522,7 @@
           <a:lstStyle/>
           <a:p>
             <a:pPr algn="ctr"/>
+            <a:endParaRPr/>
           </a:p>
         </p:txBody>
       </p:sp>
@@ -3536,7 +3543,7 @@
           <a:noFill/>
         </p:spPr>
         <p:txBody>
-          <a:bodyPr wrap="square" lIns="0" rIns="0" tIns="0" bIns="0" anchor="t">
+          <a:bodyPr wrap="square" lIns="0" tIns="0" rIns="0" bIns="0" anchor="t">
             <a:spAutoFit/>
           </a:bodyPr>
           <a:lstStyle/>
@@ -3571,7 +3578,7 @@
           <a:noFill/>
         </p:spPr>
         <p:txBody>
-          <a:bodyPr wrap="square" lIns="0" rIns="0" tIns="0" bIns="0" anchor="t">
+          <a:bodyPr wrap="square" lIns="0" tIns="0" rIns="0" bIns="0" anchor="t">
             <a:spAutoFit/>
           </a:bodyPr>
           <a:lstStyle/>
@@ -3598,7 +3605,7 @@
 </file>
 
 <file path=ppt/slides/slide2.xml><?xml version="1.0" encoding="utf-8"?>
-<p:sld xmlns:a="http://schemas.openxmlformats.org/drawingml/2006/main" xmlns:p="http://schemas.openxmlformats.org/presentationml/2006/main" xmlns:r="http://schemas.openxmlformats.org/officeDocument/2006/relationships">
+<p:sld xmlns:a="http://schemas.openxmlformats.org/drawingml/2006/main" xmlns:r="http://schemas.openxmlformats.org/officeDocument/2006/relationships" xmlns:p="http://schemas.openxmlformats.org/presentationml/2006/main">
   <p:cSld>
     <p:spTree>
       <p:nvGrpSpPr>
@@ -3606,7 +3613,14 @@
         <p:cNvGrpSpPr/>
         <p:nvPr/>
       </p:nvGrpSpPr>
-      <p:grpSpPr/>
+      <p:grpSpPr>
+        <a:xfrm>
+          <a:off x="0" y="0"/>
+          <a:ext cx="0" cy="0"/>
+          <a:chOff x="0" y="0"/>
+          <a:chExt cx="0" cy="0"/>
+        </a:xfrm>
+      </p:grpSpPr>
       <p:sp>
         <p:nvSpPr>
           <p:cNvPr id="2" name="Rectangle 1"/>
@@ -3647,6 +3661,7 @@
           <a:lstStyle/>
           <a:p>
             <a:pPr algn="ctr"/>
+            <a:endParaRPr/>
           </a:p>
         </p:txBody>
       </p:sp>
@@ -3667,7 +3682,7 @@
           <a:noFill/>
         </p:spPr>
         <p:txBody>
-          <a:bodyPr wrap="square" lIns="0" rIns="0" tIns="0" bIns="0" anchor="t">
+          <a:bodyPr wrap="square" lIns="0" tIns="0" rIns="0" bIns="0" anchor="t">
             <a:spAutoFit/>
           </a:bodyPr>
           <a:lstStyle/>
@@ -3702,7 +3717,7 @@
           <a:noFill/>
         </p:spPr>
         <p:txBody>
-          <a:bodyPr wrap="square" lIns="0" rIns="0" tIns="0" bIns="0" anchor="t">
+          <a:bodyPr wrap="square" lIns="0" tIns="0" rIns="0" bIns="0" anchor="t">
             <a:spAutoFit/>
           </a:bodyPr>
           <a:lstStyle/>
@@ -3737,7 +3752,7 @@
           <a:noFill/>
         </p:spPr>
         <p:txBody>
-          <a:bodyPr wrap="square" lIns="0" rIns="0" tIns="0" bIns="0" anchor="t">
+          <a:bodyPr wrap="square" lIns="0" tIns="0" rIns="0" bIns="0" anchor="t">
             <a:spAutoFit/>
           </a:bodyPr>
           <a:lstStyle/>
@@ -3772,7 +3787,7 @@
           <a:noFill/>
         </p:spPr>
         <p:txBody>
-          <a:bodyPr wrap="square" lIns="0" rIns="0" tIns="0" bIns="0" anchor="t">
+          <a:bodyPr wrap="square" lIns="0" tIns="0" rIns="0" bIns="0" anchor="t">
             <a:spAutoFit/>
           </a:bodyPr>
           <a:lstStyle/>
@@ -3807,7 +3822,7 @@
           <a:noFill/>
         </p:spPr>
         <p:txBody>
-          <a:bodyPr wrap="square" lIns="0" rIns="0" tIns="0" bIns="0" anchor="t">
+          <a:bodyPr wrap="square" lIns="0" tIns="0" rIns="0" bIns="0" anchor="t">
             <a:spAutoFit/>
           </a:bodyPr>
           <a:lstStyle/>
@@ -3842,7 +3857,7 @@
           <a:noFill/>
         </p:spPr>
         <p:txBody>
-          <a:bodyPr wrap="square" lIns="0" rIns="0" tIns="0" bIns="0" anchor="t">
+          <a:bodyPr wrap="square" lIns="0" tIns="0" rIns="0" bIns="0" anchor="t">
             <a:spAutoFit/>
           </a:bodyPr>
           <a:lstStyle/>
@@ -3877,7 +3892,7 @@
           <a:noFill/>
         </p:spPr>
         <p:txBody>
-          <a:bodyPr wrap="square" lIns="0" rIns="0" tIns="0" bIns="0" anchor="t">
+          <a:bodyPr wrap="square" lIns="0" tIns="0" rIns="0" bIns="0" anchor="t">
             <a:spAutoFit/>
           </a:bodyPr>
           <a:lstStyle/>
@@ -3912,7 +3927,7 @@
           <a:noFill/>
         </p:spPr>
         <p:txBody>
-          <a:bodyPr wrap="square" lIns="0" rIns="0" tIns="0" bIns="0" anchor="t">
+          <a:bodyPr wrap="square" lIns="0" tIns="0" rIns="0" bIns="0" anchor="t">
             <a:spAutoFit/>
           </a:bodyPr>
           <a:lstStyle/>
@@ -3947,7 +3962,7 @@
           <a:noFill/>
         </p:spPr>
         <p:txBody>
-          <a:bodyPr wrap="square" lIns="0" rIns="0" tIns="0" bIns="0" anchor="t">
+          <a:bodyPr wrap="square" lIns="0" tIns="0" rIns="0" bIns="0" anchor="t">
             <a:spAutoFit/>
           </a:bodyPr>
           <a:lstStyle/>
@@ -3982,7 +3997,7 @@
           <a:noFill/>
         </p:spPr>
         <p:txBody>
-          <a:bodyPr wrap="square" lIns="0" rIns="0" tIns="0" bIns="0" anchor="t">
+          <a:bodyPr wrap="square" lIns="0" tIns="0" rIns="0" bIns="0" anchor="t">
             <a:spAutoFit/>
           </a:bodyPr>
           <a:lstStyle/>
@@ -4017,7 +4032,7 @@
           <a:noFill/>
         </p:spPr>
         <p:txBody>
-          <a:bodyPr wrap="square" lIns="0" rIns="0" tIns="0" bIns="0" anchor="t">
+          <a:bodyPr wrap="square" lIns="0" tIns="0" rIns="0" bIns="0" anchor="t">
             <a:spAutoFit/>
           </a:bodyPr>
           <a:lstStyle/>
@@ -4052,7 +4067,7 @@
           <a:noFill/>
         </p:spPr>
         <p:txBody>
-          <a:bodyPr wrap="square" lIns="0" rIns="0" tIns="0" bIns="0" anchor="t">
+          <a:bodyPr wrap="square" lIns="0" tIns="0" rIns="0" bIns="0" anchor="t">
             <a:spAutoFit/>
           </a:bodyPr>
           <a:lstStyle/>
@@ -4087,7 +4102,7 @@
           <a:noFill/>
         </p:spPr>
         <p:txBody>
-          <a:bodyPr wrap="square" lIns="0" rIns="0" tIns="0" bIns="0" anchor="t">
+          <a:bodyPr wrap="square" lIns="0" tIns="0" rIns="0" bIns="0" anchor="t">
             <a:spAutoFit/>
           </a:bodyPr>
           <a:lstStyle/>
@@ -4114,7 +4129,7 @@
 </file>
 
 <file path=ppt/slides/slide3.xml><?xml version="1.0" encoding="utf-8"?>
-<p:sld xmlns:a="http://schemas.openxmlformats.org/drawingml/2006/main" xmlns:p="http://schemas.openxmlformats.org/presentationml/2006/main" xmlns:r="http://schemas.openxmlformats.org/officeDocument/2006/relationships">
+<p:sld xmlns:a="http://schemas.openxmlformats.org/drawingml/2006/main" xmlns:r="http://schemas.openxmlformats.org/officeDocument/2006/relationships" xmlns:p="http://schemas.openxmlformats.org/presentationml/2006/main">
   <p:cSld>
     <p:spTree>
       <p:nvGrpSpPr>
@@ -4122,7 +4137,14 @@
         <p:cNvGrpSpPr/>
         <p:nvPr/>
       </p:nvGrpSpPr>
-      <p:grpSpPr/>
+      <p:grpSpPr>
+        <a:xfrm>
+          <a:off x="0" y="0"/>
+          <a:ext cx="0" cy="0"/>
+          <a:chOff x="0" y="0"/>
+          <a:chExt cx="0" cy="0"/>
+        </a:xfrm>
+      </p:grpSpPr>
       <p:sp>
         <p:nvSpPr>
           <p:cNvPr id="2" name="Rectangle 1"/>
@@ -4163,6 +4185,7 @@
           <a:lstStyle/>
           <a:p>
             <a:pPr algn="ctr"/>
+            <a:endParaRPr/>
           </a:p>
         </p:txBody>
       </p:sp>
@@ -4183,7 +4206,7 @@
           <a:noFill/>
         </p:spPr>
         <p:txBody>
-          <a:bodyPr wrap="square" lIns="0" rIns="0" tIns="0" bIns="0" anchor="t">
+          <a:bodyPr wrap="square" lIns="0" tIns="0" rIns="0" bIns="0" anchor="t">
             <a:spAutoFit/>
           </a:bodyPr>
           <a:lstStyle/>
@@ -4218,7 +4241,7 @@
           <a:noFill/>
         </p:spPr>
         <p:txBody>
-          <a:bodyPr wrap="square" lIns="0" rIns="0" tIns="0" bIns="0" anchor="t">
+          <a:bodyPr wrap="square" lIns="0" tIns="0" rIns="0" bIns="0" anchor="t">
             <a:spAutoFit/>
           </a:bodyPr>
           <a:lstStyle/>
@@ -4253,7 +4276,7 @@
           <a:noFill/>
         </p:spPr>
         <p:txBody>
-          <a:bodyPr wrap="square" lIns="0" rIns="0" tIns="0" bIns="0" anchor="t">
+          <a:bodyPr wrap="square" lIns="0" tIns="0" rIns="0" bIns="0" anchor="t">
             <a:spAutoFit/>
           </a:bodyPr>
           <a:lstStyle/>
@@ -4288,7 +4311,7 @@
           <a:noFill/>
         </p:spPr>
         <p:txBody>
-          <a:bodyPr wrap="square" lIns="0" rIns="0" tIns="0" bIns="0" anchor="t">
+          <a:bodyPr wrap="square" lIns="0" tIns="0" rIns="0" bIns="0" anchor="t">
             <a:spAutoFit/>
           </a:bodyPr>
           <a:lstStyle/>
@@ -4350,6 +4373,7 @@
           <a:lstStyle/>
           <a:p>
             <a:pPr algn="ctr"/>
+            <a:endParaRPr/>
           </a:p>
         </p:txBody>
       </p:sp>
@@ -4393,6 +4417,7 @@
           <a:lstStyle/>
           <a:p>
             <a:pPr algn="ctr"/>
+            <a:endParaRPr/>
           </a:p>
         </p:txBody>
       </p:sp>
@@ -4413,7 +4438,7 @@
           <a:noFill/>
         </p:spPr>
         <p:txBody>
-          <a:bodyPr wrap="square" lIns="0" rIns="0" tIns="0" bIns="0" anchor="t">
+          <a:bodyPr wrap="square" lIns="0" tIns="0" rIns="0" bIns="0" anchor="t">
             <a:spAutoFit/>
           </a:bodyPr>
           <a:lstStyle/>
@@ -4448,7 +4473,7 @@
           <a:noFill/>
         </p:spPr>
         <p:txBody>
-          <a:bodyPr wrap="square" lIns="0" rIns="0" tIns="0" bIns="0" anchor="t">
+          <a:bodyPr wrap="square" lIns="0" tIns="0" rIns="0" bIns="0" anchor="t">
             <a:spAutoFit/>
           </a:bodyPr>
           <a:lstStyle/>
@@ -4483,7 +4508,7 @@
           <a:noFill/>
         </p:spPr>
         <p:txBody>
-          <a:bodyPr wrap="square" lIns="0" rIns="0" tIns="0" bIns="0" anchor="t">
+          <a:bodyPr wrap="square" lIns="0" tIns="0" rIns="0" bIns="0" anchor="t">
             <a:spAutoFit/>
           </a:bodyPr>
           <a:lstStyle/>
@@ -4545,6 +4570,7 @@
           <a:lstStyle/>
           <a:p>
             <a:pPr algn="ctr"/>
+            <a:endParaRPr/>
           </a:p>
         </p:txBody>
       </p:sp>
@@ -4588,6 +4614,7 @@
           <a:lstStyle/>
           <a:p>
             <a:pPr algn="ctr"/>
+            <a:endParaRPr/>
           </a:p>
         </p:txBody>
       </p:sp>
@@ -4608,7 +4635,7 @@
           <a:noFill/>
         </p:spPr>
         <p:txBody>
-          <a:bodyPr wrap="square" lIns="0" rIns="0" tIns="0" bIns="0" anchor="t">
+          <a:bodyPr wrap="square" lIns="0" tIns="0" rIns="0" bIns="0" anchor="t">
             <a:spAutoFit/>
           </a:bodyPr>
           <a:lstStyle/>
@@ -4643,7 +4670,7 @@
           <a:noFill/>
         </p:spPr>
         <p:txBody>
-          <a:bodyPr wrap="square" lIns="0" rIns="0" tIns="0" bIns="0" anchor="t">
+          <a:bodyPr wrap="square" lIns="0" tIns="0" rIns="0" bIns="0" anchor="t">
             <a:spAutoFit/>
           </a:bodyPr>
           <a:lstStyle/>
@@ -4678,7 +4705,7 @@
           <a:noFill/>
         </p:spPr>
         <p:txBody>
-          <a:bodyPr wrap="square" lIns="0" rIns="0" tIns="0" bIns="0" anchor="t">
+          <a:bodyPr wrap="square" lIns="0" tIns="0" rIns="0" bIns="0" anchor="t">
             <a:spAutoFit/>
           </a:bodyPr>
           <a:lstStyle/>
@@ -4740,6 +4767,7 @@
           <a:lstStyle/>
           <a:p>
             <a:pPr algn="ctr"/>
+            <a:endParaRPr/>
           </a:p>
         </p:txBody>
       </p:sp>
@@ -4783,6 +4811,7 @@
           <a:lstStyle/>
           <a:p>
             <a:pPr algn="ctr"/>
+            <a:endParaRPr/>
           </a:p>
         </p:txBody>
       </p:sp>
@@ -4803,7 +4832,7 @@
           <a:noFill/>
         </p:spPr>
         <p:txBody>
-          <a:bodyPr wrap="square" lIns="0" rIns="0" tIns="0" bIns="0" anchor="t">
+          <a:bodyPr wrap="square" lIns="0" tIns="0" rIns="0" bIns="0" anchor="t">
             <a:spAutoFit/>
           </a:bodyPr>
           <a:lstStyle/>
@@ -4838,7 +4867,7 @@
           <a:noFill/>
         </p:spPr>
         <p:txBody>
-          <a:bodyPr wrap="square" lIns="0" rIns="0" tIns="0" bIns="0" anchor="t">
+          <a:bodyPr wrap="square" lIns="0" tIns="0" rIns="0" bIns="0" anchor="t">
             <a:spAutoFit/>
           </a:bodyPr>
           <a:lstStyle/>
@@ -4873,7 +4902,7 @@
           <a:noFill/>
         </p:spPr>
         <p:txBody>
-          <a:bodyPr wrap="square" lIns="0" rIns="0" tIns="0" bIns="0" anchor="t">
+          <a:bodyPr wrap="square" lIns="0" tIns="0" rIns="0" bIns="0" anchor="t">
             <a:spAutoFit/>
           </a:bodyPr>
           <a:lstStyle/>
@@ -4935,6 +4964,7 @@
           <a:lstStyle/>
           <a:p>
             <a:pPr algn="ctr"/>
+            <a:endParaRPr/>
           </a:p>
         </p:txBody>
       </p:sp>
@@ -4978,6 +5008,7 @@
           <a:lstStyle/>
           <a:p>
             <a:pPr algn="ctr"/>
+            <a:endParaRPr/>
           </a:p>
         </p:txBody>
       </p:sp>
@@ -4998,7 +5029,7 @@
           <a:noFill/>
         </p:spPr>
         <p:txBody>
-          <a:bodyPr wrap="square" lIns="0" rIns="0" tIns="0" bIns="0" anchor="t">
+          <a:bodyPr wrap="square" lIns="0" tIns="0" rIns="0" bIns="0" anchor="t">
             <a:spAutoFit/>
           </a:bodyPr>
           <a:lstStyle/>
@@ -5033,7 +5064,7 @@
           <a:noFill/>
         </p:spPr>
         <p:txBody>
-          <a:bodyPr wrap="square" lIns="0" rIns="0" tIns="0" bIns="0" anchor="t">
+          <a:bodyPr wrap="square" lIns="0" tIns="0" rIns="0" bIns="0" anchor="t">
             <a:spAutoFit/>
           </a:bodyPr>
           <a:lstStyle/>
@@ -5068,7 +5099,7 @@
           <a:noFill/>
         </p:spPr>
         <p:txBody>
-          <a:bodyPr wrap="square" lIns="0" rIns="0" tIns="0" bIns="0" anchor="t">
+          <a:bodyPr wrap="square" lIns="0" tIns="0" rIns="0" bIns="0" anchor="t">
             <a:spAutoFit/>
           </a:bodyPr>
           <a:lstStyle/>
@@ -5095,7 +5126,7 @@
 </file>
 
 <file path=ppt/slides/slide4.xml><?xml version="1.0" encoding="utf-8"?>
-<p:sld xmlns:a="http://schemas.openxmlformats.org/drawingml/2006/main" xmlns:p="http://schemas.openxmlformats.org/presentationml/2006/main" xmlns:r="http://schemas.openxmlformats.org/officeDocument/2006/relationships">
+<p:sld xmlns:a="http://schemas.openxmlformats.org/drawingml/2006/main" xmlns:r="http://schemas.openxmlformats.org/officeDocument/2006/relationships" xmlns:p="http://schemas.openxmlformats.org/presentationml/2006/main">
   <p:cSld>
     <p:spTree>
       <p:nvGrpSpPr>
@@ -5103,7 +5134,14 @@
         <p:cNvGrpSpPr/>
         <p:nvPr/>
       </p:nvGrpSpPr>
-      <p:grpSpPr/>
+      <p:grpSpPr>
+        <a:xfrm>
+          <a:off x="0" y="0"/>
+          <a:ext cx="0" cy="0"/>
+          <a:chOff x="0" y="0"/>
+          <a:chExt cx="0" cy="0"/>
+        </a:xfrm>
+      </p:grpSpPr>
       <p:sp>
         <p:nvSpPr>
           <p:cNvPr id="2" name="Rectangle 1"/>
@@ -5144,6 +5182,7 @@
           <a:lstStyle/>
           <a:p>
             <a:pPr algn="ctr"/>
+            <a:endParaRPr/>
           </a:p>
         </p:txBody>
       </p:sp>
@@ -5164,7 +5203,7 @@
           <a:noFill/>
         </p:spPr>
         <p:txBody>
-          <a:bodyPr wrap="square" lIns="0" rIns="0" tIns="0" bIns="0" anchor="t">
+          <a:bodyPr wrap="square" lIns="0" tIns="0" rIns="0" bIns="0" anchor="t">
             <a:spAutoFit/>
           </a:bodyPr>
           <a:lstStyle/>
@@ -5199,7 +5238,7 @@
           <a:noFill/>
         </p:spPr>
         <p:txBody>
-          <a:bodyPr wrap="square" lIns="0" rIns="0" tIns="0" bIns="0" anchor="t">
+          <a:bodyPr wrap="square" lIns="0" tIns="0" rIns="0" bIns="0" anchor="t">
             <a:spAutoFit/>
           </a:bodyPr>
           <a:lstStyle/>
@@ -5261,6 +5300,7 @@
           <a:lstStyle/>
           <a:p>
             <a:pPr algn="ctr"/>
+            <a:endParaRPr/>
           </a:p>
         </p:txBody>
       </p:sp>
@@ -5281,7 +5321,7 @@
           <a:noFill/>
         </p:spPr>
         <p:txBody>
-          <a:bodyPr wrap="square" lIns="0" rIns="0" tIns="0" bIns="0" anchor="t">
+          <a:bodyPr wrap="square" lIns="0" tIns="0" rIns="0" bIns="0" anchor="t">
             <a:spAutoFit/>
           </a:bodyPr>
           <a:lstStyle/>
@@ -5316,7 +5356,7 @@
           <a:noFill/>
         </p:spPr>
         <p:txBody>
-          <a:bodyPr wrap="square" lIns="0" rIns="0" tIns="0" bIns="0" anchor="t">
+          <a:bodyPr wrap="square" lIns="0" tIns="0" rIns="0" bIns="0" anchor="t">
             <a:spAutoFit/>
           </a:bodyPr>
           <a:lstStyle/>
@@ -5351,7 +5391,7 @@
           <a:noFill/>
         </p:spPr>
         <p:txBody>
-          <a:bodyPr wrap="square" lIns="0" rIns="0" tIns="0" bIns="0" anchor="t">
+          <a:bodyPr wrap="square" lIns="0" tIns="0" rIns="0" bIns="0" anchor="t">
             <a:spAutoFit/>
           </a:bodyPr>
           <a:lstStyle/>
@@ -5386,7 +5426,7 @@
           <a:noFill/>
         </p:spPr>
         <p:txBody>
-          <a:bodyPr wrap="square" lIns="0" rIns="0" tIns="0" bIns="0" anchor="t">
+          <a:bodyPr wrap="square" lIns="0" tIns="0" rIns="0" bIns="0" anchor="t">
             <a:spAutoFit/>
           </a:bodyPr>
           <a:lstStyle/>
@@ -5421,7 +5461,7 @@
           <a:noFill/>
         </p:spPr>
         <p:txBody>
-          <a:bodyPr wrap="square" lIns="0" rIns="0" tIns="0" bIns="0" anchor="t">
+          <a:bodyPr wrap="square" lIns="0" tIns="0" rIns="0" bIns="0" anchor="t">
             <a:spAutoFit/>
           </a:bodyPr>
           <a:lstStyle/>
@@ -5483,6 +5523,7 @@
           <a:lstStyle/>
           <a:p>
             <a:pPr algn="ctr"/>
+            <a:endParaRPr/>
           </a:p>
         </p:txBody>
       </p:sp>
@@ -5503,7 +5544,7 @@
           <a:noFill/>
         </p:spPr>
         <p:txBody>
-          <a:bodyPr wrap="square" lIns="0" rIns="0" tIns="0" bIns="0" anchor="t">
+          <a:bodyPr wrap="square" lIns="0" tIns="0" rIns="0" bIns="0" anchor="t">
             <a:spAutoFit/>
           </a:bodyPr>
           <a:lstStyle/>
@@ -5538,7 +5579,7 @@
           <a:noFill/>
         </p:spPr>
         <p:txBody>
-          <a:bodyPr wrap="square" lIns="0" rIns="0" tIns="0" bIns="0" anchor="t">
+          <a:bodyPr wrap="square" lIns="0" tIns="0" rIns="0" bIns="0" anchor="t">
             <a:spAutoFit/>
           </a:bodyPr>
           <a:lstStyle/>
@@ -5573,7 +5614,7 @@
           <a:noFill/>
         </p:spPr>
         <p:txBody>
-          <a:bodyPr wrap="square" lIns="0" rIns="0" tIns="0" bIns="0" anchor="t">
+          <a:bodyPr wrap="square" lIns="0" tIns="0" rIns="0" bIns="0" anchor="t">
             <a:spAutoFit/>
           </a:bodyPr>
           <a:lstStyle/>
@@ -5608,7 +5649,7 @@
           <a:noFill/>
         </p:spPr>
         <p:txBody>
-          <a:bodyPr wrap="square" lIns="0" rIns="0" tIns="0" bIns="0" anchor="t">
+          <a:bodyPr wrap="square" lIns="0" tIns="0" rIns="0" bIns="0" anchor="t">
             <a:spAutoFit/>
           </a:bodyPr>
           <a:lstStyle/>
@@ -5643,7 +5684,7 @@
           <a:noFill/>
         </p:spPr>
         <p:txBody>
-          <a:bodyPr wrap="square" lIns="0" rIns="0" tIns="0" bIns="0" anchor="t">
+          <a:bodyPr wrap="square" lIns="0" tIns="0" rIns="0" bIns="0" anchor="t">
             <a:spAutoFit/>
           </a:bodyPr>
           <a:lstStyle/>
@@ -5705,6 +5746,7 @@
           <a:lstStyle/>
           <a:p>
             <a:pPr algn="ctr"/>
+            <a:endParaRPr/>
           </a:p>
         </p:txBody>
       </p:sp>
@@ -5725,7 +5767,7 @@
           <a:noFill/>
         </p:spPr>
         <p:txBody>
-          <a:bodyPr wrap="square" lIns="0" rIns="0" tIns="0" bIns="0" anchor="t">
+          <a:bodyPr wrap="square" lIns="0" tIns="0" rIns="0" bIns="0" anchor="t">
             <a:spAutoFit/>
           </a:bodyPr>
           <a:lstStyle/>
@@ -5760,7 +5802,7 @@
           <a:noFill/>
         </p:spPr>
         <p:txBody>
-          <a:bodyPr wrap="square" lIns="0" rIns="0" tIns="0" bIns="0" anchor="t">
+          <a:bodyPr wrap="square" lIns="0" tIns="0" rIns="0" bIns="0" anchor="t">
             <a:spAutoFit/>
           </a:bodyPr>
           <a:lstStyle/>
@@ -5795,7 +5837,7 @@
           <a:noFill/>
         </p:spPr>
         <p:txBody>
-          <a:bodyPr wrap="square" lIns="0" rIns="0" tIns="0" bIns="0" anchor="t">
+          <a:bodyPr wrap="square" lIns="0" tIns="0" rIns="0" bIns="0" anchor="t">
             <a:spAutoFit/>
           </a:bodyPr>
           <a:lstStyle/>
@@ -5853,6 +5895,7 @@
           <a:lstStyle/>
           <a:p>
             <a:pPr algn="ctr"/>
+            <a:endParaRPr/>
           </a:p>
         </p:txBody>
       </p:sp>
@@ -5896,6 +5939,7 @@
           <a:lstStyle/>
           <a:p>
             <a:pPr algn="ctr"/>
+            <a:endParaRPr/>
           </a:p>
         </p:txBody>
       </p:sp>
@@ -5939,6 +5983,7 @@
           <a:lstStyle/>
           <a:p>
             <a:pPr algn="ctr"/>
+            <a:endParaRPr/>
           </a:p>
         </p:txBody>
       </p:sp>
@@ -5982,6 +6027,7 @@
           <a:lstStyle/>
           <a:p>
             <a:pPr algn="ctr"/>
+            <a:endParaRPr/>
           </a:p>
         </p:txBody>
       </p:sp>
@@ -6002,7 +6048,7 @@
           <a:noFill/>
         </p:spPr>
         <p:txBody>
-          <a:bodyPr wrap="square" lIns="0" rIns="0" tIns="0" bIns="0" anchor="t">
+          <a:bodyPr wrap="square" lIns="0" tIns="0" rIns="0" bIns="0" anchor="t">
             <a:spAutoFit/>
           </a:bodyPr>
           <a:lstStyle/>
@@ -6064,6 +6110,7 @@
           <a:lstStyle/>
           <a:p>
             <a:pPr algn="ctr"/>
+            <a:endParaRPr/>
           </a:p>
         </p:txBody>
       </p:sp>
@@ -6084,7 +6131,7 @@
           <a:noFill/>
         </p:spPr>
         <p:txBody>
-          <a:bodyPr wrap="square" lIns="0" rIns="0" tIns="0" bIns="0" anchor="t">
+          <a:bodyPr wrap="square" lIns="0" tIns="0" rIns="0" bIns="0" anchor="t">
             <a:spAutoFit/>
           </a:bodyPr>
           <a:lstStyle/>
@@ -6119,7 +6166,7 @@
           <a:noFill/>
         </p:spPr>
         <p:txBody>
-          <a:bodyPr wrap="square" lIns="0" rIns="0" tIns="0" bIns="0" anchor="t">
+          <a:bodyPr wrap="square" lIns="0" tIns="0" rIns="0" bIns="0" anchor="t">
             <a:spAutoFit/>
           </a:bodyPr>
           <a:lstStyle/>
@@ -6154,7 +6201,7 @@
           <a:noFill/>
         </p:spPr>
         <p:txBody>
-          <a:bodyPr wrap="square" lIns="0" rIns="0" tIns="0" bIns="0" anchor="t">
+          <a:bodyPr wrap="square" lIns="0" tIns="0" rIns="0" bIns="0" anchor="t">
             <a:spAutoFit/>
           </a:bodyPr>
           <a:lstStyle/>
@@ -6189,7 +6236,7 @@
           <a:noFill/>
         </p:spPr>
         <p:txBody>
-          <a:bodyPr wrap="square" lIns="0" rIns="0" tIns="0" bIns="0" anchor="t">
+          <a:bodyPr wrap="square" lIns="0" tIns="0" rIns="0" bIns="0" anchor="t">
             <a:spAutoFit/>
           </a:bodyPr>
           <a:lstStyle/>
@@ -6224,7 +6271,7 @@
           <a:noFill/>
         </p:spPr>
         <p:txBody>
-          <a:bodyPr wrap="square" lIns="0" rIns="0" tIns="0" bIns="0" anchor="t">
+          <a:bodyPr wrap="square" lIns="0" tIns="0" rIns="0" bIns="0" anchor="t">
             <a:spAutoFit/>
           </a:bodyPr>
           <a:lstStyle/>
@@ -6259,7 +6306,7 @@
           <a:noFill/>
         </p:spPr>
         <p:txBody>
-          <a:bodyPr wrap="square" lIns="0" rIns="0" tIns="0" bIns="0" anchor="t">
+          <a:bodyPr wrap="square" lIns="0" tIns="0" rIns="0" bIns="0" anchor="t">
             <a:spAutoFit/>
           </a:bodyPr>
           <a:lstStyle/>
@@ -6294,7 +6341,7 @@
           <a:noFill/>
         </p:spPr>
         <p:txBody>
-          <a:bodyPr wrap="square" lIns="0" rIns="0" tIns="0" bIns="0" anchor="t">
+          <a:bodyPr wrap="square" lIns="0" tIns="0" rIns="0" bIns="0" anchor="t">
             <a:spAutoFit/>
           </a:bodyPr>
           <a:lstStyle/>
@@ -6338,7 +6385,7 @@
           <a:noFill/>
         </p:spPr>
         <p:txBody>
-          <a:bodyPr wrap="square" lIns="0" rIns="0" tIns="0" bIns="0" anchor="t">
+          <a:bodyPr wrap="square" lIns="0" tIns="0" rIns="0" bIns="0" anchor="t">
             <a:spAutoFit/>
           </a:bodyPr>
           <a:lstStyle/>
@@ -6382,7 +6429,7 @@
           <a:noFill/>
         </p:spPr>
         <p:txBody>
-          <a:bodyPr wrap="square" lIns="0" rIns="0" tIns="0" bIns="0" anchor="t">
+          <a:bodyPr wrap="square" lIns="0" tIns="0" rIns="0" bIns="0" anchor="t">
             <a:spAutoFit/>
           </a:bodyPr>
           <a:lstStyle/>
@@ -6418,7 +6465,7 @@
 </file>
 
 <file path=ppt/slides/slide5.xml><?xml version="1.0" encoding="utf-8"?>
-<p:sld xmlns:a="http://schemas.openxmlformats.org/drawingml/2006/main" xmlns:p="http://schemas.openxmlformats.org/presentationml/2006/main" xmlns:r="http://schemas.openxmlformats.org/officeDocument/2006/relationships">
+<p:sld xmlns:a="http://schemas.openxmlformats.org/drawingml/2006/main" xmlns:r="http://schemas.openxmlformats.org/officeDocument/2006/relationships" xmlns:p="http://schemas.openxmlformats.org/presentationml/2006/main">
   <p:cSld>
     <p:spTree>
       <p:nvGrpSpPr>
@@ -6426,7 +6473,14 @@
         <p:cNvGrpSpPr/>
         <p:nvPr/>
       </p:nvGrpSpPr>
-      <p:grpSpPr/>
+      <p:grpSpPr>
+        <a:xfrm>
+          <a:off x="0" y="0"/>
+          <a:ext cx="0" cy="0"/>
+          <a:chOff x="0" y="0"/>
+          <a:chExt cx="0" cy="0"/>
+        </a:xfrm>
+      </p:grpSpPr>
       <p:sp>
         <p:nvSpPr>
           <p:cNvPr id="2" name="Rectangle 1"/>
@@ -6467,6 +6521,7 @@
           <a:lstStyle/>
           <a:p>
             <a:pPr algn="ctr"/>
+            <a:endParaRPr/>
           </a:p>
         </p:txBody>
       </p:sp>
@@ -6487,7 +6542,7 @@
           <a:noFill/>
         </p:spPr>
         <p:txBody>
-          <a:bodyPr wrap="square" lIns="0" rIns="0" tIns="0" bIns="0" anchor="t">
+          <a:bodyPr wrap="square" lIns="0" tIns="0" rIns="0" bIns="0" anchor="t">
             <a:spAutoFit/>
           </a:bodyPr>
           <a:lstStyle/>
@@ -6522,7 +6577,7 @@
           <a:noFill/>
         </p:spPr>
         <p:txBody>
-          <a:bodyPr wrap="square" lIns="0" rIns="0" tIns="0" bIns="0" anchor="t">
+          <a:bodyPr wrap="square" lIns="0" tIns="0" rIns="0" bIns="0" anchor="t">
             <a:spAutoFit/>
           </a:bodyPr>
           <a:lstStyle/>
@@ -6584,6 +6639,7 @@
           <a:lstStyle/>
           <a:p>
             <a:pPr algn="ctr"/>
+            <a:endParaRPr/>
           </a:p>
         </p:txBody>
       </p:sp>
@@ -6604,7 +6660,7 @@
           <a:noFill/>
         </p:spPr>
         <p:txBody>
-          <a:bodyPr wrap="square" lIns="0" rIns="0" tIns="0" bIns="0" anchor="t">
+          <a:bodyPr wrap="square" lIns="0" tIns="0" rIns="0" bIns="0" anchor="t">
             <a:spAutoFit/>
           </a:bodyPr>
           <a:lstStyle/>
@@ -6639,7 +6695,7 @@
           <a:noFill/>
         </p:spPr>
         <p:txBody>
-          <a:bodyPr wrap="square" lIns="0" rIns="0" tIns="0" bIns="0" anchor="t">
+          <a:bodyPr wrap="square" lIns="0" tIns="0" rIns="0" bIns="0" anchor="t">
             <a:spAutoFit/>
           </a:bodyPr>
           <a:lstStyle/>
@@ -6674,7 +6730,7 @@
           <a:noFill/>
         </p:spPr>
         <p:txBody>
-          <a:bodyPr wrap="square" lIns="0" rIns="0" tIns="0" bIns="0" anchor="t">
+          <a:bodyPr wrap="square" lIns="0" tIns="0" rIns="0" bIns="0" anchor="t">
             <a:spAutoFit/>
           </a:bodyPr>
           <a:lstStyle/>
@@ -6736,6 +6792,7 @@
           <a:lstStyle/>
           <a:p>
             <a:pPr algn="ctr"/>
+            <a:endParaRPr/>
           </a:p>
         </p:txBody>
       </p:sp>
@@ -6756,7 +6813,7 @@
           <a:noFill/>
         </p:spPr>
         <p:txBody>
-          <a:bodyPr wrap="square" lIns="0" rIns="0" tIns="0" bIns="0" anchor="t">
+          <a:bodyPr wrap="square" lIns="0" tIns="0" rIns="0" bIns="0" anchor="t">
             <a:spAutoFit/>
           </a:bodyPr>
           <a:lstStyle/>
@@ -6791,7 +6848,7 @@
           <a:noFill/>
         </p:spPr>
         <p:txBody>
-          <a:bodyPr wrap="square" lIns="0" rIns="0" tIns="0" bIns="0" anchor="t">
+          <a:bodyPr wrap="square" lIns="0" tIns="0" rIns="0" bIns="0" anchor="t">
             <a:spAutoFit/>
           </a:bodyPr>
           <a:lstStyle/>
@@ -6826,7 +6883,7 @@
           <a:noFill/>
         </p:spPr>
         <p:txBody>
-          <a:bodyPr wrap="square" lIns="0" rIns="0" tIns="0" bIns="0" anchor="t">
+          <a:bodyPr wrap="square" lIns="0" tIns="0" rIns="0" bIns="0" anchor="t">
             <a:spAutoFit/>
           </a:bodyPr>
           <a:lstStyle/>
@@ -6888,6 +6945,7 @@
           <a:lstStyle/>
           <a:p>
             <a:pPr algn="ctr"/>
+            <a:endParaRPr/>
           </a:p>
         </p:txBody>
       </p:sp>
@@ -6908,7 +6966,7 @@
           <a:noFill/>
         </p:spPr>
         <p:txBody>
-          <a:bodyPr wrap="square" lIns="0" rIns="0" tIns="0" bIns="0" anchor="t">
+          <a:bodyPr wrap="square" lIns="0" tIns="0" rIns="0" bIns="0" anchor="t">
             <a:spAutoFit/>
           </a:bodyPr>
           <a:lstStyle/>
@@ -6943,7 +7001,7 @@
           <a:noFill/>
         </p:spPr>
         <p:txBody>
-          <a:bodyPr wrap="square" lIns="0" rIns="0" tIns="0" bIns="0" anchor="t">
+          <a:bodyPr wrap="square" lIns="0" tIns="0" rIns="0" bIns="0" anchor="t">
             <a:spAutoFit/>
           </a:bodyPr>
           <a:lstStyle/>
@@ -6978,7 +7036,7 @@
           <a:noFill/>
         </p:spPr>
         <p:txBody>
-          <a:bodyPr wrap="square" lIns="0" rIns="0" tIns="0" bIns="0" anchor="t">
+          <a:bodyPr wrap="square" lIns="0" tIns="0" rIns="0" bIns="0" anchor="t">
             <a:spAutoFit/>
           </a:bodyPr>
           <a:lstStyle/>
@@ -7040,6 +7098,7 @@
           <a:lstStyle/>
           <a:p>
             <a:pPr algn="ctr"/>
+            <a:endParaRPr/>
           </a:p>
         </p:txBody>
       </p:sp>
@@ -7060,7 +7119,7 @@
           <a:noFill/>
         </p:spPr>
         <p:txBody>
-          <a:bodyPr wrap="square" lIns="0" rIns="0" tIns="0" bIns="0" anchor="t">
+          <a:bodyPr wrap="square" lIns="0" tIns="0" rIns="0" bIns="0" anchor="t">
             <a:spAutoFit/>
           </a:bodyPr>
           <a:lstStyle/>
@@ -7095,7 +7154,7 @@
           <a:noFill/>
         </p:spPr>
         <p:txBody>
-          <a:bodyPr wrap="square" lIns="0" rIns="0" tIns="0" bIns="0" anchor="t">
+          <a:bodyPr wrap="square" lIns="0" tIns="0" rIns="0" bIns="0" anchor="t">
             <a:spAutoFit/>
           </a:bodyPr>
           <a:lstStyle/>
@@ -7130,7 +7189,7 @@
           <a:noFill/>
         </p:spPr>
         <p:txBody>
-          <a:bodyPr wrap="square" lIns="0" rIns="0" tIns="0" bIns="0" anchor="t">
+          <a:bodyPr wrap="square" lIns="0" tIns="0" rIns="0" bIns="0" anchor="t">
             <a:spAutoFit/>
           </a:bodyPr>
           <a:lstStyle/>
@@ -7165,7 +7224,7 @@
           <a:noFill/>
         </p:spPr>
         <p:txBody>
-          <a:bodyPr wrap="square" lIns="0" rIns="0" tIns="0" bIns="0" anchor="t">
+          <a:bodyPr wrap="square" lIns="0" tIns="0" rIns="0" bIns="0" anchor="t">
             <a:spAutoFit/>
           </a:bodyPr>
           <a:lstStyle/>
@@ -7192,7 +7251,7 @@
 </file>
 
 <file path=ppt/slides/slide6.xml><?xml version="1.0" encoding="utf-8"?>
-<p:sld xmlns:a="http://schemas.openxmlformats.org/drawingml/2006/main" xmlns:p="http://schemas.openxmlformats.org/presentationml/2006/main" xmlns:r="http://schemas.openxmlformats.org/officeDocument/2006/relationships">
+<p:sld xmlns:a="http://schemas.openxmlformats.org/drawingml/2006/main" xmlns:r="http://schemas.openxmlformats.org/officeDocument/2006/relationships" xmlns:p="http://schemas.openxmlformats.org/presentationml/2006/main">
   <p:cSld>
     <p:spTree>
       <p:nvGrpSpPr>
@@ -7200,7 +7259,14 @@
         <p:cNvGrpSpPr/>
         <p:nvPr/>
       </p:nvGrpSpPr>
-      <p:grpSpPr/>
+      <p:grpSpPr>
+        <a:xfrm>
+          <a:off x="0" y="0"/>
+          <a:ext cx="0" cy="0"/>
+          <a:chOff x="0" y="0"/>
+          <a:chExt cx="0" cy="0"/>
+        </a:xfrm>
+      </p:grpSpPr>
       <p:sp>
         <p:nvSpPr>
           <p:cNvPr id="2" name="Rectangle 1"/>
@@ -7241,6 +7307,7 @@
           <a:lstStyle/>
           <a:p>
             <a:pPr algn="ctr"/>
+            <a:endParaRPr/>
           </a:p>
         </p:txBody>
       </p:sp>
@@ -7261,7 +7328,7 @@
           <a:noFill/>
         </p:spPr>
         <p:txBody>
-          <a:bodyPr wrap="square" lIns="0" rIns="0" tIns="0" bIns="0" anchor="t">
+          <a:bodyPr wrap="square" lIns="0" tIns="0" rIns="0" bIns="0" anchor="t">
             <a:spAutoFit/>
           </a:bodyPr>
           <a:lstStyle/>
@@ -7296,7 +7363,7 @@
           <a:noFill/>
         </p:spPr>
         <p:txBody>
-          <a:bodyPr wrap="square" lIns="0" rIns="0" tIns="0" bIns="0" anchor="t">
+          <a:bodyPr wrap="square" lIns="0" tIns="0" rIns="0" bIns="0" anchor="t">
             <a:spAutoFit/>
           </a:bodyPr>
           <a:lstStyle/>
@@ -7358,6 +7425,7 @@
           <a:lstStyle/>
           <a:p>
             <a:pPr algn="ctr"/>
+            <a:endParaRPr/>
           </a:p>
         </p:txBody>
       </p:sp>
@@ -7401,6 +7469,7 @@
           <a:lstStyle/>
           <a:p>
             <a:pPr algn="ctr"/>
+            <a:endParaRPr/>
           </a:p>
         </p:txBody>
       </p:sp>
@@ -7421,7 +7490,7 @@
           <a:noFill/>
         </p:spPr>
         <p:txBody>
-          <a:bodyPr wrap="square" lIns="0" rIns="0" tIns="0" bIns="0" anchor="t">
+          <a:bodyPr wrap="square" lIns="0" tIns="0" rIns="0" bIns="0" anchor="t">
             <a:spAutoFit/>
           </a:bodyPr>
           <a:lstStyle/>
@@ -7456,7 +7525,7 @@
           <a:noFill/>
         </p:spPr>
         <p:txBody>
-          <a:bodyPr wrap="square" lIns="0" rIns="0" tIns="0" bIns="0" anchor="t">
+          <a:bodyPr wrap="square" lIns="0" tIns="0" rIns="0" bIns="0" anchor="t">
             <a:spAutoFit/>
           </a:bodyPr>
           <a:lstStyle/>
@@ -7491,7 +7560,7 @@
           <a:noFill/>
         </p:spPr>
         <p:txBody>
-          <a:bodyPr wrap="square" lIns="0" rIns="0" tIns="0" bIns="0" anchor="t">
+          <a:bodyPr wrap="square" lIns="0" tIns="0" rIns="0" bIns="0" anchor="t">
             <a:spAutoFit/>
           </a:bodyPr>
           <a:lstStyle/>
@@ -7526,7 +7595,7 @@
           <a:noFill/>
         </p:spPr>
         <p:txBody>
-          <a:bodyPr wrap="square" lIns="0" rIns="0" tIns="0" bIns="0" anchor="t">
+          <a:bodyPr wrap="square" lIns="0" tIns="0" rIns="0" bIns="0" anchor="t">
             <a:spAutoFit/>
           </a:bodyPr>
           <a:lstStyle/>
@@ -7570,7 +7639,7 @@
           <a:noFill/>
         </p:spPr>
         <p:txBody>
-          <a:bodyPr wrap="square" lIns="0" rIns="0" tIns="0" bIns="0" anchor="t">
+          <a:bodyPr wrap="square" lIns="0" tIns="0" rIns="0" bIns="0" anchor="t">
             <a:spAutoFit/>
           </a:bodyPr>
           <a:lstStyle/>
@@ -7614,7 +7683,7 @@
           <a:noFill/>
         </p:spPr>
         <p:txBody>
-          <a:bodyPr wrap="square" lIns="0" rIns="0" tIns="0" bIns="0" anchor="t">
+          <a:bodyPr wrap="square" lIns="0" tIns="0" rIns="0" bIns="0" anchor="t">
             <a:spAutoFit/>
           </a:bodyPr>
           <a:lstStyle/>
@@ -7658,7 +7727,7 @@
           <a:noFill/>
         </p:spPr>
         <p:txBody>
-          <a:bodyPr wrap="square" lIns="0" rIns="0" tIns="0" bIns="0" anchor="t">
+          <a:bodyPr wrap="square" lIns="0" tIns="0" rIns="0" bIns="0" anchor="t">
             <a:spAutoFit/>
           </a:bodyPr>
           <a:lstStyle/>
@@ -7729,6 +7798,7 @@
           <a:lstStyle/>
           <a:p>
             <a:pPr algn="ctr"/>
+            <a:endParaRPr/>
           </a:p>
         </p:txBody>
       </p:sp>
@@ -7772,6 +7842,7 @@
           <a:lstStyle/>
           <a:p>
             <a:pPr algn="ctr"/>
+            <a:endParaRPr/>
           </a:p>
         </p:txBody>
       </p:sp>
@@ -7792,7 +7863,7 @@
           <a:noFill/>
         </p:spPr>
         <p:txBody>
-          <a:bodyPr wrap="square" lIns="0" rIns="0" tIns="0" bIns="0" anchor="t">
+          <a:bodyPr wrap="square" lIns="0" tIns="0" rIns="0" bIns="0" anchor="t">
             <a:spAutoFit/>
           </a:bodyPr>
           <a:lstStyle/>
@@ -7827,7 +7898,7 @@
           <a:noFill/>
         </p:spPr>
         <p:txBody>
-          <a:bodyPr wrap="square" lIns="0" rIns="0" tIns="0" bIns="0" anchor="t">
+          <a:bodyPr wrap="square" lIns="0" tIns="0" rIns="0" bIns="0" anchor="t">
             <a:spAutoFit/>
           </a:bodyPr>
           <a:lstStyle/>
@@ -7862,7 +7933,7 @@
           <a:noFill/>
         </p:spPr>
         <p:txBody>
-          <a:bodyPr wrap="square" lIns="0" rIns="0" tIns="0" bIns="0" anchor="t">
+          <a:bodyPr wrap="square" lIns="0" tIns="0" rIns="0" bIns="0" anchor="t">
             <a:spAutoFit/>
           </a:bodyPr>
           <a:lstStyle/>
@@ -7897,7 +7968,7 @@
           <a:noFill/>
         </p:spPr>
         <p:txBody>
-          <a:bodyPr wrap="square" lIns="0" rIns="0" tIns="0" bIns="0" anchor="t">
+          <a:bodyPr wrap="square" lIns="0" tIns="0" rIns="0" bIns="0" anchor="t">
             <a:spAutoFit/>
           </a:bodyPr>
           <a:lstStyle/>
@@ -7941,7 +8012,7 @@
           <a:noFill/>
         </p:spPr>
         <p:txBody>
-          <a:bodyPr wrap="square" lIns="0" rIns="0" tIns="0" bIns="0" anchor="t">
+          <a:bodyPr wrap="square" lIns="0" tIns="0" rIns="0" bIns="0" anchor="t">
             <a:spAutoFit/>
           </a:bodyPr>
           <a:lstStyle/>
@@ -7985,7 +8056,7 @@
           <a:noFill/>
         </p:spPr>
         <p:txBody>
-          <a:bodyPr wrap="square" lIns="0" rIns="0" tIns="0" bIns="0" anchor="t">
+          <a:bodyPr wrap="square" lIns="0" tIns="0" rIns="0" bIns="0" anchor="t">
             <a:spAutoFit/>
           </a:bodyPr>
           <a:lstStyle/>
@@ -8029,7 +8100,7 @@
           <a:noFill/>
         </p:spPr>
         <p:txBody>
-          <a:bodyPr wrap="square" lIns="0" rIns="0" tIns="0" bIns="0" anchor="t">
+          <a:bodyPr wrap="square" lIns="0" tIns="0" rIns="0" bIns="0" anchor="t">
             <a:spAutoFit/>
           </a:bodyPr>
           <a:lstStyle/>
@@ -8073,7 +8144,7 @@
           <a:noFill/>
         </p:spPr>
         <p:txBody>
-          <a:bodyPr wrap="square" lIns="0" rIns="0" tIns="0" bIns="0" anchor="t">
+          <a:bodyPr wrap="square" lIns="0" tIns="0" rIns="0" bIns="0" anchor="t">
             <a:spAutoFit/>
           </a:bodyPr>
           <a:lstStyle/>
@@ -8144,6 +8215,7 @@
           <a:lstStyle/>
           <a:p>
             <a:pPr algn="ctr"/>
+            <a:endParaRPr/>
           </a:p>
         </p:txBody>
       </p:sp>
@@ -8187,6 +8259,7 @@
           <a:lstStyle/>
           <a:p>
             <a:pPr algn="ctr"/>
+            <a:endParaRPr/>
           </a:p>
         </p:txBody>
       </p:sp>
@@ -8207,7 +8280,7 @@
           <a:noFill/>
         </p:spPr>
         <p:txBody>
-          <a:bodyPr wrap="square" lIns="0" rIns="0" tIns="0" bIns="0" anchor="t">
+          <a:bodyPr wrap="square" lIns="0" tIns="0" rIns="0" bIns="0" anchor="t">
             <a:spAutoFit/>
           </a:bodyPr>
           <a:lstStyle/>
@@ -8242,7 +8315,7 @@
           <a:noFill/>
         </p:spPr>
         <p:txBody>
-          <a:bodyPr wrap="square" lIns="0" rIns="0" tIns="0" bIns="0" anchor="t">
+          <a:bodyPr wrap="square" lIns="0" tIns="0" rIns="0" bIns="0" anchor="t">
             <a:spAutoFit/>
           </a:bodyPr>
           <a:lstStyle/>
@@ -8277,7 +8350,7 @@
           <a:noFill/>
         </p:spPr>
         <p:txBody>
-          <a:bodyPr wrap="square" lIns="0" rIns="0" tIns="0" bIns="0" anchor="t">
+          <a:bodyPr wrap="square" lIns="0" tIns="0" rIns="0" bIns="0" anchor="t">
             <a:spAutoFit/>
           </a:bodyPr>
           <a:lstStyle/>
@@ -8312,7 +8385,7 @@
           <a:noFill/>
         </p:spPr>
         <p:txBody>
-          <a:bodyPr wrap="square" lIns="0" rIns="0" tIns="0" bIns="0" anchor="t">
+          <a:bodyPr wrap="square" lIns="0" tIns="0" rIns="0" bIns="0" anchor="t">
             <a:spAutoFit/>
           </a:bodyPr>
           <a:lstStyle/>
@@ -8356,7 +8429,7 @@
           <a:noFill/>
         </p:spPr>
         <p:txBody>
-          <a:bodyPr wrap="square" lIns="0" rIns="0" tIns="0" bIns="0" anchor="t">
+          <a:bodyPr wrap="square" lIns="0" tIns="0" rIns="0" bIns="0" anchor="t">
             <a:spAutoFit/>
           </a:bodyPr>
           <a:lstStyle/>
@@ -8400,7 +8473,7 @@
           <a:noFill/>
         </p:spPr>
         <p:txBody>
-          <a:bodyPr wrap="square" lIns="0" rIns="0" tIns="0" bIns="0" anchor="t">
+          <a:bodyPr wrap="square" lIns="0" tIns="0" rIns="0" bIns="0" anchor="t">
             <a:spAutoFit/>
           </a:bodyPr>
           <a:lstStyle/>
@@ -8444,7 +8517,7 @@
           <a:noFill/>
         </p:spPr>
         <p:txBody>
-          <a:bodyPr wrap="square" lIns="0" rIns="0" tIns="0" bIns="0" anchor="t">
+          <a:bodyPr wrap="square" lIns="0" tIns="0" rIns="0" bIns="0" anchor="t">
             <a:spAutoFit/>
           </a:bodyPr>
           <a:lstStyle/>
@@ -8480,7 +8553,7 @@
 </file>
 
 <file path=ppt/slides/slide7.xml><?xml version="1.0" encoding="utf-8"?>
-<p:sld xmlns:a="http://schemas.openxmlformats.org/drawingml/2006/main" xmlns:p="http://schemas.openxmlformats.org/presentationml/2006/main" xmlns:r="http://schemas.openxmlformats.org/officeDocument/2006/relationships">
+<p:sld xmlns:a="http://schemas.openxmlformats.org/drawingml/2006/main" xmlns:r="http://schemas.openxmlformats.org/officeDocument/2006/relationships" xmlns:p="http://schemas.openxmlformats.org/presentationml/2006/main">
   <p:cSld>
     <p:spTree>
       <p:nvGrpSpPr>
@@ -8488,7 +8561,14 @@
         <p:cNvGrpSpPr/>
         <p:nvPr/>
       </p:nvGrpSpPr>
-      <p:grpSpPr/>
+      <p:grpSpPr>
+        <a:xfrm>
+          <a:off x="0" y="0"/>
+          <a:ext cx="0" cy="0"/>
+          <a:chOff x="0" y="0"/>
+          <a:chExt cx="0" cy="0"/>
+        </a:xfrm>
+      </p:grpSpPr>
       <p:sp>
         <p:nvSpPr>
           <p:cNvPr id="2" name="Rectangle 1"/>
@@ -8529,6 +8609,7 @@
           <a:lstStyle/>
           <a:p>
             <a:pPr algn="ctr"/>
+            <a:endParaRPr/>
           </a:p>
         </p:txBody>
       </p:sp>
@@ -8549,7 +8630,7 @@
           <a:noFill/>
         </p:spPr>
         <p:txBody>
-          <a:bodyPr wrap="square" lIns="0" rIns="0" tIns="0" bIns="0" anchor="t">
+          <a:bodyPr wrap="square" lIns="0" tIns="0" rIns="0" bIns="0" anchor="t">
             <a:spAutoFit/>
           </a:bodyPr>
           <a:lstStyle/>
@@ -8584,7 +8665,7 @@
           <a:noFill/>
         </p:spPr>
         <p:txBody>
-          <a:bodyPr wrap="square" lIns="0" rIns="0" tIns="0" bIns="0" anchor="t">
+          <a:bodyPr wrap="square" lIns="0" tIns="0" rIns="0" bIns="0" anchor="t">
             <a:spAutoFit/>
           </a:bodyPr>
           <a:lstStyle/>
@@ -8646,6 +8727,7 @@
           <a:lstStyle/>
           <a:p>
             <a:pPr algn="ctr"/>
+            <a:endParaRPr/>
           </a:p>
         </p:txBody>
       </p:sp>
@@ -8666,7 +8748,7 @@
           <a:noFill/>
         </p:spPr>
         <p:txBody>
-          <a:bodyPr wrap="square" lIns="0" rIns="0" tIns="0" bIns="0" anchor="t">
+          <a:bodyPr wrap="square" lIns="0" tIns="0" rIns="0" bIns="0" anchor="t">
             <a:spAutoFit/>
           </a:bodyPr>
           <a:lstStyle/>
@@ -8701,7 +8783,7 @@
           <a:noFill/>
         </p:spPr>
         <p:txBody>
-          <a:bodyPr wrap="square" lIns="0" rIns="0" tIns="0" bIns="0" anchor="t">
+          <a:bodyPr wrap="square" lIns="0" tIns="0" rIns="0" bIns="0" anchor="t">
             <a:spAutoFit/>
           </a:bodyPr>
           <a:lstStyle/>
@@ -8763,6 +8845,7 @@
           <a:lstStyle/>
           <a:p>
             <a:pPr algn="ctr"/>
+            <a:endParaRPr/>
           </a:p>
         </p:txBody>
       </p:sp>
@@ -8783,7 +8866,7 @@
           <a:noFill/>
         </p:spPr>
         <p:txBody>
-          <a:bodyPr wrap="square" lIns="0" rIns="0" tIns="0" bIns="0" anchor="t">
+          <a:bodyPr wrap="square" lIns="0" tIns="0" rIns="0" bIns="0" anchor="t">
             <a:spAutoFit/>
           </a:bodyPr>
           <a:lstStyle/>
@@ -8818,7 +8901,7 @@
           <a:noFill/>
         </p:spPr>
         <p:txBody>
-          <a:bodyPr wrap="square" lIns="0" rIns="0" tIns="0" bIns="0" anchor="t">
+          <a:bodyPr wrap="square" lIns="0" tIns="0" rIns="0" bIns="0" anchor="t">
             <a:spAutoFit/>
           </a:bodyPr>
           <a:lstStyle/>
@@ -8853,7 +8936,7 @@
           <a:noFill/>
         </p:spPr>
         <p:txBody>
-          <a:bodyPr wrap="square" lIns="0" rIns="0" tIns="0" bIns="0" anchor="t">
+          <a:bodyPr wrap="square" lIns="0" tIns="0" rIns="0" bIns="0" anchor="t">
             <a:spAutoFit/>
           </a:bodyPr>
           <a:lstStyle/>
@@ -8888,7 +8971,7 @@
           <a:noFill/>
         </p:spPr>
         <p:txBody>
-          <a:bodyPr wrap="square" lIns="0" rIns="0" tIns="0" bIns="0" anchor="t">
+          <a:bodyPr wrap="square" lIns="0" tIns="0" rIns="0" bIns="0" anchor="t">
             <a:spAutoFit/>
           </a:bodyPr>
           <a:lstStyle/>
@@ -8923,7 +9006,7 @@
           <a:noFill/>
         </p:spPr>
         <p:txBody>
-          <a:bodyPr wrap="square" lIns="0" rIns="0" tIns="0" bIns="0" anchor="t">
+          <a:bodyPr wrap="square" lIns="0" tIns="0" rIns="0" bIns="0" anchor="t">
             <a:spAutoFit/>
           </a:bodyPr>
           <a:lstStyle/>

</xml_diff>